<commit_message>
fix(deck): switch presentation to a light, high-contrast theme
The dark theme rendered as unreadable in PowerPoint (light text with no dark
background). Rebuild the same 15-slide deck on an off-white palette with dark
ink, subtle card shadows, and screenshots in white cards — legible and easy to
present.

Co-Authored-By: Claude Opus 4.8 <noreply@anthropic.com>
</commit_message>
<xml_diff>
--- a/presentation/Clinical_Policy_RAG.pptx
+++ b/presentation/Clinical_Policy_RAG.pptx
@@ -2103,7 +2103,7 @@
     <p:bg>
       <p:bgPr>
         <a:solidFill>
-          <a:srgbClr val="0B0B0F"/>
+          <a:srgbClr val="F7F8FA"/>
         </a:solidFill>
       </p:bgPr>
     </p:bg>
@@ -2138,13 +2138,13 @@
             </a:avLst>
           </a:prstGeom>
           <a:solidFill>
-            <a:srgbClr val="8B5CF6"/>
+            <a:srgbClr val="6D28D9"/>
           </a:solidFill>
           <a:ln/>
           <a:effectLst>
-            <a:outerShdw sx="100000" sy="100000" kx="0" ky="0" algn="bl" rotWithShape="0" blurRad="279400" dist="50800" dir="16200000">
-              <a:srgbClr val="E1348B">
-                <a:alpha val="50000"/>
+            <a:outerShdw sx="100000" sy="100000" kx="0" ky="0" algn="bl" rotWithShape="0" blurRad="203200" dist="50800" dir="16200000">
+              <a:srgbClr val="DB2777">
+                <a:alpha val="28000"/>
               </a:srgbClr>
             </a:outerShdw>
           </a:effectLst>
@@ -2204,7 +2204,7 @@
             <a:avLst/>
           </a:prstGeom>
           <a:solidFill>
-            <a:srgbClr val="8B5CF6"/>
+            <a:srgbClr val="6D28D9"/>
           </a:solidFill>
           <a:ln/>
         </p:spPr>
@@ -2236,7 +2236,7 @@
             <a:r>
               <a:rPr lang="en-US" sz="1200" b="1" spc="200" kern="0" dirty="0">
                 <a:solidFill>
-                  <a:srgbClr val="8B5CF6"/>
+                  <a:srgbClr val="6D28D9"/>
                 </a:solidFill>
                 <a:latin typeface="Courier New" pitchFamily="34" charset="0"/>
                 <a:ea typeface="Courier New" pitchFamily="34" charset="-122"/>
@@ -2275,7 +2275,7 @@
             <a:r>
               <a:rPr lang="en-US" sz="5400" b="1" dirty="0">
                 <a:solidFill>
-                  <a:srgbClr val="F5F5F7"/>
+                  <a:srgbClr val="16171F"/>
                 </a:solidFill>
                 <a:latin typeface="Arial" pitchFamily="34" charset="0"/>
                 <a:ea typeface="Arial" pitchFamily="34" charset="-122"/>
@@ -2317,7 +2317,7 @@
             <a:r>
               <a:rPr lang="en-US" sz="1700" dirty="0">
                 <a:solidFill>
-                  <a:srgbClr val="9CA0AE"/>
+                  <a:srgbClr val="5C6472"/>
                 </a:solidFill>
                 <a:latin typeface="Calibri" pitchFamily="34" charset="0"/>
                 <a:ea typeface="Calibri" pitchFamily="34" charset="-122"/>
@@ -2337,7 +2337,7 @@
             <a:r>
               <a:rPr lang="en-US" sz="1700" dirty="0">
                 <a:solidFill>
-                  <a:srgbClr val="9CA0AE"/>
+                  <a:srgbClr val="5C6472"/>
                 </a:solidFill>
                 <a:latin typeface="Calibri" pitchFamily="34" charset="0"/>
                 <a:ea typeface="Calibri" pitchFamily="34" charset="-122"/>
@@ -2366,7 +2366,7 @@
           <a:noFill/>
           <a:ln w="12700">
             <a:solidFill>
-              <a:srgbClr val="24242E"/>
+              <a:srgbClr val="E4E7ED"/>
             </a:solidFill>
             <a:prstDash val="solid"/>
           </a:ln>
@@ -2399,7 +2399,7 @@
             <a:r>
               <a:rPr lang="en-US" sz="1400" b="1" dirty="0">
                 <a:solidFill>
-                  <a:srgbClr val="F5F5F7"/>
+                  <a:srgbClr val="16171F"/>
                 </a:solidFill>
                 <a:latin typeface="Calibri" pitchFamily="34" charset="0"/>
                 <a:ea typeface="Calibri" pitchFamily="34" charset="-122"/>
@@ -2413,7 +2413,7 @@
             <a:r>
               <a:rPr lang="en-US" sz="1400" dirty="0">
                 <a:solidFill>
-                  <a:srgbClr val="9CA0AE"/>
+                  <a:srgbClr val="5C6472"/>
                 </a:solidFill>
                 <a:latin typeface="Calibri" pitchFamily="34" charset="0"/>
                 <a:ea typeface="Calibri" pitchFamily="34" charset="-122"/>
@@ -2452,7 +2452,7 @@
             <a:r>
               <a:rPr lang="en-US" sz="1100" dirty="0">
                 <a:solidFill>
-                  <a:srgbClr val="6B7280"/>
+                  <a:srgbClr val="9AA0AC"/>
                 </a:solidFill>
                 <a:latin typeface="Courier New" pitchFamily="34" charset="0"/>
                 <a:ea typeface="Courier New" pitchFamily="34" charset="-122"/>
@@ -2478,7 +2478,7 @@
     <p:bg>
       <p:bgPr>
         <a:solidFill>
-          <a:srgbClr val="0B0B0F"/>
+          <a:srgbClr val="F7F8FA"/>
         </a:solidFill>
       </p:bgPr>
     </p:bg>
@@ -2511,7 +2511,7 @@
             <a:avLst/>
           </a:prstGeom>
           <a:solidFill>
-            <a:srgbClr val="8B5CF6"/>
+            <a:srgbClr val="6D28D9"/>
           </a:solidFill>
           <a:ln/>
         </p:spPr>
@@ -2543,7 +2543,7 @@
             <a:r>
               <a:rPr lang="en-US" sz="1100" b="1" spc="200" kern="0" dirty="0">
                 <a:solidFill>
-                  <a:srgbClr val="8B5CF6"/>
+                  <a:srgbClr val="6D28D9"/>
                 </a:solidFill>
                 <a:latin typeface="Courier New" pitchFamily="34" charset="0"/>
                 <a:ea typeface="Courier New" pitchFamily="34" charset="-122"/>
@@ -2585,7 +2585,7 @@
             <a:r>
               <a:rPr lang="en-US" sz="2900" b="1" dirty="0">
                 <a:solidFill>
-                  <a:srgbClr val="F5F5F7"/>
+                  <a:srgbClr val="16171F"/>
                 </a:solidFill>
                 <a:latin typeface="Arial" pitchFamily="34" charset="0"/>
                 <a:ea typeface="Arial" pitchFamily="34" charset="-122"/>
@@ -2602,7 +2602,7 @@
             <a:r>
               <a:rPr lang="en-US" sz="2900" b="1" dirty="0">
                 <a:solidFill>
-                  <a:srgbClr val="10B981"/>
+                  <a:srgbClr val="059669"/>
                 </a:solidFill>
                 <a:latin typeface="Arial" pitchFamily="34" charset="0"/>
                 <a:ea typeface="Arial" pitchFamily="34" charset="-122"/>
@@ -2641,7 +2641,7 @@
             <a:r>
               <a:rPr lang="en-US" sz="800" spc="200" kern="0" dirty="0">
                 <a:solidFill>
-                  <a:srgbClr val="6B7280"/>
+                  <a:srgbClr val="9AA0AC"/>
                 </a:solidFill>
                 <a:latin typeface="Courier New" pitchFamily="34" charset="0"/>
                 <a:ea typeface="Courier New" pitchFamily="34" charset="-122"/>
@@ -2680,7 +2680,7 @@
             <a:r>
               <a:rPr lang="en-US" sz="800" dirty="0">
                 <a:solidFill>
-                  <a:srgbClr val="6B7280"/>
+                  <a:srgbClr val="9AA0AC"/>
                 </a:solidFill>
                 <a:latin typeface="Courier New" pitchFamily="34" charset="0"/>
                 <a:ea typeface="Courier New" pitchFamily="34" charset="-122"/>
@@ -2713,14 +2713,14 @@
           </a:solidFill>
           <a:ln w="12700">
             <a:solidFill>
-              <a:srgbClr val="24242E"/>
+              <a:srgbClr val="E4E7ED"/>
             </a:solidFill>
             <a:prstDash val="solid"/>
           </a:ln>
           <a:effectLst>
-            <a:outerShdw sx="100000" sy="100000" kx="0" ky="0" algn="bl" rotWithShape="0" blurRad="203200" dist="50800" dir="5400000">
-              <a:srgbClr val="000000">
-                <a:alpha val="45000"/>
+            <a:outerShdw sx="100000" sy="100000" kx="0" ky="0" algn="bl" rotWithShape="0" blurRad="139700" dist="38100" dir="5400000">
+              <a:srgbClr val="8A93A6">
+                <a:alpha val="30000"/>
               </a:srgbClr>
             </a:outerShdw>
           </a:effectLst>
@@ -2780,7 +2780,7 @@
             <a:r>
               <a:rPr lang="en-US" sz="1300" i="1" dirty="0">
                 <a:solidFill>
-                  <a:srgbClr val="9CA0AE"/>
+                  <a:srgbClr val="5C6472"/>
                 </a:solidFill>
                 <a:latin typeface="Calibri" pitchFamily="34" charset="0"/>
                 <a:ea typeface="Calibri" pitchFamily="34" charset="-122"/>
@@ -2806,7 +2806,7 @@
     <p:bg>
       <p:bgPr>
         <a:solidFill>
-          <a:srgbClr val="0B0B0F"/>
+          <a:srgbClr val="F7F8FA"/>
         </a:solidFill>
       </p:bgPr>
     </p:bg>
@@ -2839,7 +2839,7 @@
             <a:avLst/>
           </a:prstGeom>
           <a:solidFill>
-            <a:srgbClr val="8B5CF6"/>
+            <a:srgbClr val="6D28D9"/>
           </a:solidFill>
           <a:ln/>
         </p:spPr>
@@ -2871,7 +2871,7 @@
             <a:r>
               <a:rPr lang="en-US" sz="1100" b="1" spc="200" kern="0" dirty="0">
                 <a:solidFill>
-                  <a:srgbClr val="8B5CF6"/>
+                  <a:srgbClr val="6D28D9"/>
                 </a:solidFill>
                 <a:latin typeface="Courier New" pitchFamily="34" charset="0"/>
                 <a:ea typeface="Courier New" pitchFamily="34" charset="-122"/>
@@ -2913,7 +2913,7 @@
             <a:r>
               <a:rPr lang="en-US" sz="2900" b="1" dirty="0">
                 <a:solidFill>
-                  <a:srgbClr val="F5F5F7"/>
+                  <a:srgbClr val="16171F"/>
                 </a:solidFill>
                 <a:latin typeface="Arial" pitchFamily="34" charset="0"/>
                 <a:ea typeface="Arial" pitchFamily="34" charset="-122"/>
@@ -2930,7 +2930,7 @@
             <a:r>
               <a:rPr lang="en-US" sz="2900" b="1" dirty="0">
                 <a:solidFill>
-                  <a:srgbClr val="F04A4A"/>
+                  <a:srgbClr val="DC2626"/>
                 </a:solidFill>
                 <a:latin typeface="Arial" pitchFamily="34" charset="0"/>
                 <a:ea typeface="Arial" pitchFamily="34" charset="-122"/>
@@ -2969,7 +2969,7 @@
             <a:r>
               <a:rPr lang="en-US" sz="800" spc="200" kern="0" dirty="0">
                 <a:solidFill>
-                  <a:srgbClr val="6B7280"/>
+                  <a:srgbClr val="9AA0AC"/>
                 </a:solidFill>
                 <a:latin typeface="Courier New" pitchFamily="34" charset="0"/>
                 <a:ea typeface="Courier New" pitchFamily="34" charset="-122"/>
@@ -3008,7 +3008,7 @@
             <a:r>
               <a:rPr lang="en-US" sz="800" dirty="0">
                 <a:solidFill>
-                  <a:srgbClr val="6B7280"/>
+                  <a:srgbClr val="9AA0AC"/>
                 </a:solidFill>
                 <a:latin typeface="Courier New" pitchFamily="34" charset="0"/>
                 <a:ea typeface="Courier New" pitchFamily="34" charset="-122"/>
@@ -3041,14 +3041,14 @@
           </a:solidFill>
           <a:ln w="12700">
             <a:solidFill>
-              <a:srgbClr val="24242E"/>
+              <a:srgbClr val="E4E7ED"/>
             </a:solidFill>
             <a:prstDash val="solid"/>
           </a:ln>
           <a:effectLst>
-            <a:outerShdw sx="100000" sy="100000" kx="0" ky="0" algn="bl" rotWithShape="0" blurRad="203200" dist="50800" dir="5400000">
-              <a:srgbClr val="000000">
-                <a:alpha val="45000"/>
+            <a:outerShdw sx="100000" sy="100000" kx="0" ky="0" algn="bl" rotWithShape="0" blurRad="139700" dist="38100" dir="5400000">
+              <a:srgbClr val="8A93A6">
+                <a:alpha val="30000"/>
               </a:srgbClr>
             </a:outerShdw>
           </a:effectLst>
@@ -3108,7 +3108,7 @@
             <a:r>
               <a:rPr lang="en-US" sz="1300" i="1" dirty="0">
                 <a:solidFill>
-                  <a:srgbClr val="9CA0AE"/>
+                  <a:srgbClr val="5C6472"/>
                 </a:solidFill>
                 <a:latin typeface="Calibri" pitchFamily="34" charset="0"/>
                 <a:ea typeface="Calibri" pitchFamily="34" charset="-122"/>
@@ -3134,7 +3134,7 @@
     <p:bg>
       <p:bgPr>
         <a:solidFill>
-          <a:srgbClr val="0B0B0F"/>
+          <a:srgbClr val="F7F8FA"/>
         </a:solidFill>
       </p:bgPr>
     </p:bg>
@@ -3167,7 +3167,7 @@
             <a:avLst/>
           </a:prstGeom>
           <a:solidFill>
-            <a:srgbClr val="8B5CF6"/>
+            <a:srgbClr val="6D28D9"/>
           </a:solidFill>
           <a:ln/>
         </p:spPr>
@@ -3199,7 +3199,7 @@
             <a:r>
               <a:rPr lang="en-US" sz="1100" b="1" spc="200" kern="0" dirty="0">
                 <a:solidFill>
-                  <a:srgbClr val="8B5CF6"/>
+                  <a:srgbClr val="6D28D9"/>
                 </a:solidFill>
                 <a:latin typeface="Courier New" pitchFamily="34" charset="0"/>
                 <a:ea typeface="Courier New" pitchFamily="34" charset="-122"/>
@@ -3241,7 +3241,7 @@
             <a:r>
               <a:rPr lang="en-US" sz="2900" b="1" dirty="0">
                 <a:solidFill>
-                  <a:srgbClr val="F5F5F7"/>
+                  <a:srgbClr val="16171F"/>
                 </a:solidFill>
                 <a:latin typeface="Arial" pitchFamily="34" charset="0"/>
                 <a:ea typeface="Arial" pitchFamily="34" charset="-122"/>
@@ -3280,7 +3280,7 @@
             <a:r>
               <a:rPr lang="en-US" sz="800" spc="200" kern="0" dirty="0">
                 <a:solidFill>
-                  <a:srgbClr val="6B7280"/>
+                  <a:srgbClr val="9AA0AC"/>
                 </a:solidFill>
                 <a:latin typeface="Courier New" pitchFamily="34" charset="0"/>
                 <a:ea typeface="Courier New" pitchFamily="34" charset="-122"/>
@@ -3319,7 +3319,7 @@
             <a:r>
               <a:rPr lang="en-US" sz="800" dirty="0">
                 <a:solidFill>
-                  <a:srgbClr val="6B7280"/>
+                  <a:srgbClr val="9AA0AC"/>
                 </a:solidFill>
                 <a:latin typeface="Courier New" pitchFamily="34" charset="0"/>
                 <a:ea typeface="Courier New" pitchFamily="34" charset="-122"/>
@@ -3352,14 +3352,14 @@
           </a:solidFill>
           <a:ln w="12700">
             <a:solidFill>
-              <a:srgbClr val="24242E"/>
+              <a:srgbClr val="E4E7ED"/>
             </a:solidFill>
             <a:prstDash val="solid"/>
           </a:ln>
           <a:effectLst>
-            <a:outerShdw sx="100000" sy="100000" kx="0" ky="0" algn="bl" rotWithShape="0" blurRad="203200" dist="50800" dir="5400000">
-              <a:srgbClr val="000000">
-                <a:alpha val="45000"/>
+            <a:outerShdw sx="100000" sy="100000" kx="0" ky="0" algn="bl" rotWithShape="0" blurRad="139700" dist="38100" dir="5400000">
+              <a:srgbClr val="8A93A6">
+                <a:alpha val="30000"/>
               </a:srgbClr>
             </a:outerShdw>
           </a:effectLst>
@@ -3419,7 +3419,7 @@
             <a:r>
               <a:rPr lang="en-US" sz="1300" i="1" dirty="0">
                 <a:solidFill>
-                  <a:srgbClr val="9CA0AE"/>
+                  <a:srgbClr val="5C6472"/>
                 </a:solidFill>
                 <a:latin typeface="Calibri" pitchFamily="34" charset="0"/>
                 <a:ea typeface="Calibri" pitchFamily="34" charset="-122"/>
@@ -3445,7 +3445,7 @@
     <p:bg>
       <p:bgPr>
         <a:solidFill>
-          <a:srgbClr val="0B0B0F"/>
+          <a:srgbClr val="F7F8FA"/>
         </a:solidFill>
       </p:bgPr>
     </p:bg>
@@ -3478,7 +3478,7 @@
             <a:avLst/>
           </a:prstGeom>
           <a:solidFill>
-            <a:srgbClr val="8B5CF6"/>
+            <a:srgbClr val="6D28D9"/>
           </a:solidFill>
           <a:ln/>
         </p:spPr>
@@ -3510,7 +3510,7 @@
             <a:r>
               <a:rPr lang="en-US" sz="1100" b="1" spc="200" kern="0" dirty="0">
                 <a:solidFill>
-                  <a:srgbClr val="8B5CF6"/>
+                  <a:srgbClr val="6D28D9"/>
                 </a:solidFill>
                 <a:latin typeface="Courier New" pitchFamily="34" charset="0"/>
                 <a:ea typeface="Courier New" pitchFamily="34" charset="-122"/>
@@ -3552,7 +3552,7 @@
             <a:r>
               <a:rPr lang="en-US" sz="2900" b="1" dirty="0">
                 <a:solidFill>
-                  <a:srgbClr val="F5F5F7"/>
+                  <a:srgbClr val="16171F"/>
                 </a:solidFill>
                 <a:latin typeface="Arial" pitchFamily="34" charset="0"/>
                 <a:ea typeface="Arial" pitchFamily="34" charset="-122"/>
@@ -3591,7 +3591,7 @@
             <a:r>
               <a:rPr lang="en-US" sz="800" spc="200" kern="0" dirty="0">
                 <a:solidFill>
-                  <a:srgbClr val="6B7280"/>
+                  <a:srgbClr val="9AA0AC"/>
                 </a:solidFill>
                 <a:latin typeface="Courier New" pitchFamily="34" charset="0"/>
                 <a:ea typeface="Courier New" pitchFamily="34" charset="-122"/>
@@ -3630,7 +3630,7 @@
             <a:r>
               <a:rPr lang="en-US" sz="800" dirty="0">
                 <a:solidFill>
-                  <a:srgbClr val="6B7280"/>
+                  <a:srgbClr val="9AA0AC"/>
                 </a:solidFill>
                 <a:latin typeface="Courier New" pitchFamily="34" charset="0"/>
                 <a:ea typeface="Courier New" pitchFamily="34" charset="-122"/>
@@ -3659,14 +3659,21 @@
             </a:avLst>
           </a:prstGeom>
           <a:solidFill>
-            <a:srgbClr val="16161C"/>
+            <a:srgbClr val="FFFFFF"/>
           </a:solidFill>
           <a:ln w="12700">
             <a:solidFill>
-              <a:srgbClr val="24242E"/>
+              <a:srgbClr val="E4E7ED"/>
             </a:solidFill>
             <a:prstDash val="solid"/>
           </a:ln>
+          <a:effectLst>
+            <a:outerShdw sx="100000" sy="100000" kx="0" ky="0" algn="bl" rotWithShape="0" blurRad="101600" dist="25400" dir="5400000">
+              <a:srgbClr val="9AA3B2">
+                <a:alpha val="22000"/>
+              </a:srgbClr>
+            </a:outerShdw>
+          </a:effectLst>
         </p:spPr>
       </p:sp>
       <p:sp>
@@ -3696,7 +3703,7 @@
             <a:r>
               <a:rPr lang="en-US" sz="1150" b="1" spc="150" kern="0" dirty="0">
                 <a:solidFill>
-                  <a:srgbClr val="10B981"/>
+                  <a:srgbClr val="059669"/>
                 </a:solidFill>
                 <a:latin typeface="Courier New" pitchFamily="34" charset="0"/>
                 <a:ea typeface="Courier New" pitchFamily="34" charset="-122"/>
@@ -3723,7 +3730,7 @@
             <a:avLst/>
           </a:prstGeom>
           <a:solidFill>
-            <a:srgbClr val="10B981"/>
+            <a:srgbClr val="059669"/>
           </a:solidFill>
           <a:ln/>
         </p:spPr>
@@ -3758,7 +3765,7 @@
             <a:r>
               <a:rPr lang="en-US" sz="1250" dirty="0">
                 <a:solidFill>
-                  <a:srgbClr val="9CA0AE"/>
+                  <a:srgbClr val="5C6472"/>
                 </a:solidFill>
                 <a:latin typeface="Calibri" pitchFamily="34" charset="0"/>
                 <a:ea typeface="Calibri" pitchFamily="34" charset="-122"/>
@@ -3785,7 +3792,7 @@
             <a:avLst/>
           </a:prstGeom>
           <a:solidFill>
-            <a:srgbClr val="10B981"/>
+            <a:srgbClr val="059669"/>
           </a:solidFill>
           <a:ln/>
         </p:spPr>
@@ -3820,7 +3827,7 @@
             <a:r>
               <a:rPr lang="en-US" sz="1250" dirty="0">
                 <a:solidFill>
-                  <a:srgbClr val="9CA0AE"/>
+                  <a:srgbClr val="5C6472"/>
                 </a:solidFill>
                 <a:latin typeface="Calibri" pitchFamily="34" charset="0"/>
                 <a:ea typeface="Calibri" pitchFamily="34" charset="-122"/>
@@ -3847,7 +3854,7 @@
             <a:avLst/>
           </a:prstGeom>
           <a:solidFill>
-            <a:srgbClr val="10B981"/>
+            <a:srgbClr val="059669"/>
           </a:solidFill>
           <a:ln/>
         </p:spPr>
@@ -3882,7 +3889,7 @@
             <a:r>
               <a:rPr lang="en-US" sz="1250" dirty="0">
                 <a:solidFill>
-                  <a:srgbClr val="9CA0AE"/>
+                  <a:srgbClr val="5C6472"/>
                 </a:solidFill>
                 <a:latin typeface="Calibri" pitchFamily="34" charset="0"/>
                 <a:ea typeface="Calibri" pitchFamily="34" charset="-122"/>
@@ -3911,14 +3918,21 @@
             </a:avLst>
           </a:prstGeom>
           <a:solidFill>
-            <a:srgbClr val="16161C"/>
+            <a:srgbClr val="FFFFFF"/>
           </a:solidFill>
           <a:ln w="12700">
             <a:solidFill>
-              <a:srgbClr val="24242E"/>
+              <a:srgbClr val="E4E7ED"/>
             </a:solidFill>
             <a:prstDash val="solid"/>
           </a:ln>
+          <a:effectLst>
+            <a:outerShdw sx="100000" sy="100000" kx="0" ky="0" algn="bl" rotWithShape="0" blurRad="101600" dist="25400" dir="5400000">
+              <a:srgbClr val="9AA3B2">
+                <a:alpha val="22000"/>
+              </a:srgbClr>
+            </a:outerShdw>
+          </a:effectLst>
         </p:spPr>
       </p:sp>
       <p:sp>
@@ -3948,7 +3962,7 @@
             <a:r>
               <a:rPr lang="en-US" sz="1150" b="1" spc="150" kern="0" dirty="0">
                 <a:solidFill>
-                  <a:srgbClr val="F04A4A"/>
+                  <a:srgbClr val="DC2626"/>
                 </a:solidFill>
                 <a:latin typeface="Courier New" pitchFamily="34" charset="0"/>
                 <a:ea typeface="Courier New" pitchFamily="34" charset="-122"/>
@@ -3975,7 +3989,7 @@
             <a:avLst/>
           </a:prstGeom>
           <a:solidFill>
-            <a:srgbClr val="F04A4A"/>
+            <a:srgbClr val="DC2626"/>
           </a:solidFill>
           <a:ln/>
         </p:spPr>
@@ -4010,7 +4024,7 @@
             <a:r>
               <a:rPr lang="en-US" sz="1250" dirty="0">
                 <a:solidFill>
-                  <a:srgbClr val="9CA0AE"/>
+                  <a:srgbClr val="5C6472"/>
                 </a:solidFill>
                 <a:latin typeface="Calibri" pitchFamily="34" charset="0"/>
                 <a:ea typeface="Calibri" pitchFamily="34" charset="-122"/>
@@ -4037,7 +4051,7 @@
             <a:avLst/>
           </a:prstGeom>
           <a:solidFill>
-            <a:srgbClr val="F04A4A"/>
+            <a:srgbClr val="DC2626"/>
           </a:solidFill>
           <a:ln/>
         </p:spPr>
@@ -4072,7 +4086,7 @@
             <a:r>
               <a:rPr lang="en-US" sz="1250" dirty="0">
                 <a:solidFill>
-                  <a:srgbClr val="9CA0AE"/>
+                  <a:srgbClr val="5C6472"/>
                 </a:solidFill>
                 <a:latin typeface="Calibri" pitchFamily="34" charset="0"/>
                 <a:ea typeface="Calibri" pitchFamily="34" charset="-122"/>
@@ -4099,7 +4113,7 @@
             <a:avLst/>
           </a:prstGeom>
           <a:solidFill>
-            <a:srgbClr val="F04A4A"/>
+            <a:srgbClr val="DC2626"/>
           </a:solidFill>
           <a:ln/>
         </p:spPr>
@@ -4134,7 +4148,7 @@
             <a:r>
               <a:rPr lang="en-US" sz="1250" dirty="0">
                 <a:solidFill>
-                  <a:srgbClr val="9CA0AE"/>
+                  <a:srgbClr val="5C6472"/>
                 </a:solidFill>
                 <a:latin typeface="Calibri" pitchFamily="34" charset="0"/>
                 <a:ea typeface="Calibri" pitchFamily="34" charset="-122"/>
@@ -4163,14 +4177,21 @@
             </a:avLst>
           </a:prstGeom>
           <a:solidFill>
-            <a:srgbClr val="0E0E15"/>
+            <a:srgbClr val="F1ECFD"/>
           </a:solidFill>
           <a:ln w="12700">
             <a:solidFill>
-              <a:srgbClr val="24242E"/>
+              <a:srgbClr val="E4E7ED"/>
             </a:solidFill>
             <a:prstDash val="solid"/>
           </a:ln>
+          <a:effectLst>
+            <a:outerShdw sx="100000" sy="100000" kx="0" ky="0" algn="bl" rotWithShape="0" blurRad="101600" dist="25400" dir="5400000">
+              <a:srgbClr val="9AA3B2">
+                <a:alpha val="22000"/>
+              </a:srgbClr>
+            </a:outerShdw>
+          </a:effectLst>
         </p:spPr>
       </p:sp>
       <p:sp>
@@ -4188,7 +4209,7 @@
             <a:avLst/>
           </a:prstGeom>
           <a:solidFill>
-            <a:srgbClr val="8B5CF6"/>
+            <a:srgbClr val="6D28D9"/>
           </a:solidFill>
           <a:ln/>
         </p:spPr>
@@ -4220,7 +4241,7 @@
             <a:r>
               <a:rPr lang="en-US" sz="1100" b="1" spc="150" kern="0" dirty="0">
                 <a:solidFill>
-                  <a:srgbClr val="8B5CF6"/>
+                  <a:srgbClr val="6D28D9"/>
                 </a:solidFill>
                 <a:latin typeface="Courier New" pitchFamily="34" charset="0"/>
                 <a:ea typeface="Courier New" pitchFamily="34" charset="-122"/>
@@ -4262,7 +4283,7 @@
             <a:r>
               <a:rPr lang="en-US" sz="1400" dirty="0">
                 <a:solidFill>
-                  <a:srgbClr val="F5F5F7"/>
+                  <a:srgbClr val="16171F"/>
                 </a:solidFill>
                 <a:latin typeface="Calibri" pitchFamily="34" charset="0"/>
                 <a:ea typeface="Calibri" pitchFamily="34" charset="-122"/>
@@ -4288,7 +4309,7 @@
     <p:bg>
       <p:bgPr>
         <a:solidFill>
-          <a:srgbClr val="0B0B0F"/>
+          <a:srgbClr val="F7F8FA"/>
         </a:solidFill>
       </p:bgPr>
     </p:bg>
@@ -4321,7 +4342,7 @@
             <a:avLst/>
           </a:prstGeom>
           <a:solidFill>
-            <a:srgbClr val="8B5CF6"/>
+            <a:srgbClr val="6D28D9"/>
           </a:solidFill>
           <a:ln/>
         </p:spPr>
@@ -4353,7 +4374,7 @@
             <a:r>
               <a:rPr lang="en-US" sz="1100" b="1" spc="200" kern="0" dirty="0">
                 <a:solidFill>
-                  <a:srgbClr val="8B5CF6"/>
+                  <a:srgbClr val="6D28D9"/>
                 </a:solidFill>
                 <a:latin typeface="Courier New" pitchFamily="34" charset="0"/>
                 <a:ea typeface="Courier New" pitchFamily="34" charset="-122"/>
@@ -4395,7 +4416,7 @@
             <a:r>
               <a:rPr lang="en-US" sz="2900" b="1" dirty="0">
                 <a:solidFill>
-                  <a:srgbClr val="F5F5F7"/>
+                  <a:srgbClr val="16171F"/>
                 </a:solidFill>
                 <a:latin typeface="Arial" pitchFamily="34" charset="0"/>
                 <a:ea typeface="Arial" pitchFamily="34" charset="-122"/>
@@ -4434,7 +4455,7 @@
             <a:r>
               <a:rPr lang="en-US" sz="800" spc="200" kern="0" dirty="0">
                 <a:solidFill>
-                  <a:srgbClr val="6B7280"/>
+                  <a:srgbClr val="9AA0AC"/>
                 </a:solidFill>
                 <a:latin typeface="Courier New" pitchFamily="34" charset="0"/>
                 <a:ea typeface="Courier New" pitchFamily="34" charset="-122"/>
@@ -4473,7 +4494,7 @@
             <a:r>
               <a:rPr lang="en-US" sz="800" dirty="0">
                 <a:solidFill>
-                  <a:srgbClr val="6B7280"/>
+                  <a:srgbClr val="9AA0AC"/>
                 </a:solidFill>
                 <a:latin typeface="Courier New" pitchFamily="34" charset="0"/>
                 <a:ea typeface="Courier New" pitchFamily="34" charset="-122"/>
@@ -4512,7 +4533,7 @@
             <a:r>
               <a:rPr lang="en-US" sz="1150" b="1" spc="150" kern="0" dirty="0">
                 <a:solidFill>
-                  <a:srgbClr val="E1348B"/>
+                  <a:srgbClr val="DB2777"/>
                 </a:solidFill>
                 <a:latin typeface="Courier New" pitchFamily="34" charset="0"/>
                 <a:ea typeface="Courier New" pitchFamily="34" charset="-122"/>
@@ -4539,7 +4560,7 @@
             <a:avLst/>
           </a:prstGeom>
           <a:solidFill>
-            <a:srgbClr val="E1348B"/>
+            <a:srgbClr val="DB2777"/>
           </a:solidFill>
           <a:ln/>
         </p:spPr>
@@ -4574,7 +4595,7 @@
             <a:r>
               <a:rPr lang="en-US" sz="1300" dirty="0">
                 <a:solidFill>
-                  <a:srgbClr val="9CA0AE"/>
+                  <a:srgbClr val="5C6472"/>
                 </a:solidFill>
                 <a:latin typeface="Calibri" pitchFamily="34" charset="0"/>
                 <a:ea typeface="Calibri" pitchFamily="34" charset="-122"/>
@@ -4601,7 +4622,7 @@
             <a:avLst/>
           </a:prstGeom>
           <a:solidFill>
-            <a:srgbClr val="E1348B"/>
+            <a:srgbClr val="DB2777"/>
           </a:solidFill>
           <a:ln/>
         </p:spPr>
@@ -4636,7 +4657,7 @@
             <a:r>
               <a:rPr lang="en-US" sz="1300" dirty="0">
                 <a:solidFill>
-                  <a:srgbClr val="9CA0AE"/>
+                  <a:srgbClr val="5C6472"/>
                 </a:solidFill>
                 <a:latin typeface="Calibri" pitchFamily="34" charset="0"/>
                 <a:ea typeface="Calibri" pitchFamily="34" charset="-122"/>
@@ -4663,7 +4684,7 @@
             <a:avLst/>
           </a:prstGeom>
           <a:solidFill>
-            <a:srgbClr val="E1348B"/>
+            <a:srgbClr val="DB2777"/>
           </a:solidFill>
           <a:ln/>
         </p:spPr>
@@ -4698,7 +4719,7 @@
             <a:r>
               <a:rPr lang="en-US" sz="1300" dirty="0">
                 <a:solidFill>
-                  <a:srgbClr val="9CA0AE"/>
+                  <a:srgbClr val="5C6472"/>
                 </a:solidFill>
                 <a:latin typeface="Calibri" pitchFamily="34" charset="0"/>
                 <a:ea typeface="Calibri" pitchFamily="34" charset="-122"/>
@@ -4737,7 +4758,7 @@
             <a:r>
               <a:rPr lang="en-US" sz="1150" b="1" spc="150" kern="0" dirty="0">
                 <a:solidFill>
-                  <a:srgbClr val="8B5CF6"/>
+                  <a:srgbClr val="6D28D9"/>
                 </a:solidFill>
                 <a:latin typeface="Courier New" pitchFamily="34" charset="0"/>
                 <a:ea typeface="Courier New" pitchFamily="34" charset="-122"/>
@@ -4764,7 +4785,7 @@
             <a:avLst/>
           </a:prstGeom>
           <a:solidFill>
-            <a:srgbClr val="8B5CF6"/>
+            <a:srgbClr val="6D28D9"/>
           </a:solidFill>
           <a:ln/>
         </p:spPr>
@@ -4799,7 +4820,7 @@
             <a:r>
               <a:rPr lang="en-US" sz="1300" dirty="0">
                 <a:solidFill>
-                  <a:srgbClr val="9CA0AE"/>
+                  <a:srgbClr val="5C6472"/>
                 </a:solidFill>
                 <a:latin typeface="Calibri" pitchFamily="34" charset="0"/>
                 <a:ea typeface="Calibri" pitchFamily="34" charset="-122"/>
@@ -4826,7 +4847,7 @@
             <a:avLst/>
           </a:prstGeom>
           <a:solidFill>
-            <a:srgbClr val="8B5CF6"/>
+            <a:srgbClr val="6D28D9"/>
           </a:solidFill>
           <a:ln/>
         </p:spPr>
@@ -4861,7 +4882,7 @@
             <a:r>
               <a:rPr lang="en-US" sz="1300" dirty="0">
                 <a:solidFill>
-                  <a:srgbClr val="9CA0AE"/>
+                  <a:srgbClr val="5C6472"/>
                 </a:solidFill>
                 <a:latin typeface="Calibri" pitchFamily="34" charset="0"/>
                 <a:ea typeface="Calibri" pitchFamily="34" charset="-122"/>
@@ -4888,7 +4909,7 @@
             <a:avLst/>
           </a:prstGeom>
           <a:solidFill>
-            <a:srgbClr val="8B5CF6"/>
+            <a:srgbClr val="6D28D9"/>
           </a:solidFill>
           <a:ln/>
         </p:spPr>
@@ -4923,7 +4944,7 @@
             <a:r>
               <a:rPr lang="en-US" sz="1300" dirty="0">
                 <a:solidFill>
-                  <a:srgbClr val="9CA0AE"/>
+                  <a:srgbClr val="5C6472"/>
                 </a:solidFill>
                 <a:latin typeface="Calibri" pitchFamily="34" charset="0"/>
                 <a:ea typeface="Calibri" pitchFamily="34" charset="-122"/>
@@ -4950,7 +4971,7 @@
             <a:avLst/>
           </a:prstGeom>
           <a:solidFill>
-            <a:srgbClr val="8B5CF6"/>
+            <a:srgbClr val="6D28D9"/>
           </a:solidFill>
           <a:ln/>
         </p:spPr>
@@ -4985,7 +5006,7 @@
             <a:r>
               <a:rPr lang="en-US" sz="1300" dirty="0">
                 <a:solidFill>
-                  <a:srgbClr val="9CA0AE"/>
+                  <a:srgbClr val="5C6472"/>
                 </a:solidFill>
                 <a:latin typeface="Calibri" pitchFamily="34" charset="0"/>
                 <a:ea typeface="Calibri" pitchFamily="34" charset="-122"/>
@@ -5011,7 +5032,7 @@
     <p:bg>
       <p:bgPr>
         <a:solidFill>
-          <a:srgbClr val="0B0B0F"/>
+          <a:srgbClr val="F7F8FA"/>
         </a:solidFill>
       </p:bgPr>
     </p:bg>
@@ -5044,7 +5065,7 @@
             <a:avLst/>
           </a:prstGeom>
           <a:solidFill>
-            <a:srgbClr val="8B5CF6"/>
+            <a:srgbClr val="6D28D9"/>
           </a:solidFill>
           <a:ln/>
         </p:spPr>
@@ -5076,7 +5097,7 @@
             <a:r>
               <a:rPr lang="en-US" sz="1200" b="1" spc="200" kern="0" dirty="0">
                 <a:solidFill>
-                  <a:srgbClr val="8B5CF6"/>
+                  <a:srgbClr val="6D28D9"/>
                 </a:solidFill>
                 <a:latin typeface="Courier New" pitchFamily="34" charset="0"/>
                 <a:ea typeface="Courier New" pitchFamily="34" charset="-122"/>
@@ -5115,7 +5136,7 @@
             <a:r>
               <a:rPr lang="en-US" sz="4800" b="1" dirty="0">
                 <a:solidFill>
-                  <a:srgbClr val="F5F5F7"/>
+                  <a:srgbClr val="16171F"/>
                 </a:solidFill>
                 <a:latin typeface="Arial" pitchFamily="34" charset="0"/>
                 <a:ea typeface="Arial" pitchFamily="34" charset="-122"/>
@@ -5154,7 +5175,7 @@
             <a:r>
               <a:rPr lang="en-US" sz="1700" dirty="0">
                 <a:solidFill>
-                  <a:srgbClr val="9CA0AE"/>
+                  <a:srgbClr val="5C6472"/>
                 </a:solidFill>
                 <a:latin typeface="Calibri" pitchFamily="34" charset="0"/>
                 <a:ea typeface="Calibri" pitchFamily="34" charset="-122"/>
@@ -5183,7 +5204,7 @@
           <a:noFill/>
           <a:ln w="12700">
             <a:solidFill>
-              <a:srgbClr val="24242E"/>
+              <a:srgbClr val="E4E7ED"/>
             </a:solidFill>
             <a:prstDash val="solid"/>
           </a:ln>
@@ -5219,7 +5240,7 @@
             <a:r>
               <a:rPr lang="en-US" sz="1250" b="1" dirty="0">
                 <a:solidFill>
-                  <a:srgbClr val="F5F5F7"/>
+                  <a:srgbClr val="16171F"/>
                 </a:solidFill>
                 <a:latin typeface="Courier New" pitchFamily="34" charset="0"/>
                 <a:ea typeface="Courier New" pitchFamily="34" charset="-122"/>
@@ -5237,7 +5258,7 @@
             <a:r>
               <a:rPr lang="en-US" sz="1250" dirty="0">
                 <a:solidFill>
-                  <a:srgbClr val="9CA0AE"/>
+                  <a:srgbClr val="5C6472"/>
                 </a:solidFill>
                 <a:latin typeface="Courier New" pitchFamily="34" charset="0"/>
                 <a:ea typeface="Courier New" pitchFamily="34" charset="-122"/>
@@ -5255,7 +5276,7 @@
             <a:r>
               <a:rPr lang="en-US" sz="1250" dirty="0">
                 <a:solidFill>
-                  <a:srgbClr val="6B7280"/>
+                  <a:srgbClr val="9AA0AC"/>
                 </a:solidFill>
                 <a:latin typeface="Courier New" pitchFamily="34" charset="0"/>
                 <a:ea typeface="Courier New" pitchFamily="34" charset="-122"/>
@@ -5281,7 +5302,7 @@
     <p:bg>
       <p:bgPr>
         <a:solidFill>
-          <a:srgbClr val="0B0B0F"/>
+          <a:srgbClr val="F7F8FA"/>
         </a:solidFill>
       </p:bgPr>
     </p:bg>
@@ -5314,7 +5335,7 @@
             <a:avLst/>
           </a:prstGeom>
           <a:solidFill>
-            <a:srgbClr val="8B5CF6"/>
+            <a:srgbClr val="6D28D9"/>
           </a:solidFill>
           <a:ln/>
         </p:spPr>
@@ -5346,7 +5367,7 @@
             <a:r>
               <a:rPr lang="en-US" sz="1100" b="1" spc="200" kern="0" dirty="0">
                 <a:solidFill>
-                  <a:srgbClr val="8B5CF6"/>
+                  <a:srgbClr val="6D28D9"/>
                 </a:solidFill>
                 <a:latin typeface="Courier New" pitchFamily="34" charset="0"/>
                 <a:ea typeface="Courier New" pitchFamily="34" charset="-122"/>
@@ -5388,7 +5409,7 @@
             <a:r>
               <a:rPr lang="en-US" sz="2900" b="1" dirty="0">
                 <a:solidFill>
-                  <a:srgbClr val="F5F5F7"/>
+                  <a:srgbClr val="16171F"/>
                 </a:solidFill>
                 <a:latin typeface="Arial" pitchFamily="34" charset="0"/>
                 <a:ea typeface="Arial" pitchFamily="34" charset="-122"/>
@@ -5427,7 +5448,7 @@
             <a:r>
               <a:rPr lang="en-US" sz="800" spc="200" kern="0" dirty="0">
                 <a:solidFill>
-                  <a:srgbClr val="6B7280"/>
+                  <a:srgbClr val="9AA0AC"/>
                 </a:solidFill>
                 <a:latin typeface="Courier New" pitchFamily="34" charset="0"/>
                 <a:ea typeface="Courier New" pitchFamily="34" charset="-122"/>
@@ -5466,7 +5487,7 @@
             <a:r>
               <a:rPr lang="en-US" sz="800" dirty="0">
                 <a:solidFill>
-                  <a:srgbClr val="6B7280"/>
+                  <a:srgbClr val="9AA0AC"/>
                 </a:solidFill>
                 <a:latin typeface="Courier New" pitchFamily="34" charset="0"/>
                 <a:ea typeface="Courier New" pitchFamily="34" charset="-122"/>
@@ -5508,7 +5529,7 @@
             <a:r>
               <a:rPr lang="en-US" sz="1550" dirty="0">
                 <a:solidFill>
-                  <a:srgbClr val="9CA0AE"/>
+                  <a:srgbClr val="5C6472"/>
                 </a:solidFill>
                 <a:latin typeface="Calibri" pitchFamily="34" charset="0"/>
                 <a:ea typeface="Calibri" pitchFamily="34" charset="-122"/>
@@ -5537,14 +5558,21 @@
             </a:avLst>
           </a:prstGeom>
           <a:solidFill>
-            <a:srgbClr val="16161C"/>
+            <a:srgbClr val="FFFFFF"/>
           </a:solidFill>
           <a:ln w="12700">
             <a:solidFill>
-              <a:srgbClr val="24242E"/>
+              <a:srgbClr val="E4E7ED"/>
             </a:solidFill>
             <a:prstDash val="solid"/>
           </a:ln>
+          <a:effectLst>
+            <a:outerShdw sx="100000" sy="100000" kx="0" ky="0" algn="bl" rotWithShape="0" blurRad="101600" dist="25400" dir="5400000">
+              <a:srgbClr val="9AA3B2">
+                <a:alpha val="22000"/>
+              </a:srgbClr>
+            </a:outerShdw>
+          </a:effectLst>
         </p:spPr>
       </p:sp>
       <p:sp>
@@ -5562,7 +5590,7 @@
             <a:avLst/>
           </a:prstGeom>
           <a:solidFill>
-            <a:srgbClr val="8B5CF6"/>
+            <a:srgbClr val="6D28D9"/>
           </a:solidFill>
           <a:ln/>
         </p:spPr>
@@ -5597,7 +5625,7 @@
             <a:r>
               <a:rPr lang="en-US" sz="1550" b="1" dirty="0">
                 <a:solidFill>
-                  <a:srgbClr val="F5F5F7"/>
+                  <a:srgbClr val="16171F"/>
                 </a:solidFill>
                 <a:latin typeface="Arial" pitchFamily="34" charset="0"/>
                 <a:ea typeface="Arial" pitchFamily="34" charset="-122"/>
@@ -5639,7 +5667,7 @@
             <a:r>
               <a:rPr lang="en-US" sz="1250" dirty="0">
                 <a:solidFill>
-                  <a:srgbClr val="9CA0AE"/>
+                  <a:srgbClr val="5C6472"/>
                 </a:solidFill>
                 <a:latin typeface="Calibri" pitchFamily="34" charset="0"/>
                 <a:ea typeface="Calibri" pitchFamily="34" charset="-122"/>
@@ -5668,14 +5696,21 @@
             </a:avLst>
           </a:prstGeom>
           <a:solidFill>
-            <a:srgbClr val="16161C"/>
+            <a:srgbClr val="FFFFFF"/>
           </a:solidFill>
           <a:ln w="12700">
             <a:solidFill>
-              <a:srgbClr val="24242E"/>
+              <a:srgbClr val="E4E7ED"/>
             </a:solidFill>
             <a:prstDash val="solid"/>
           </a:ln>
+          <a:effectLst>
+            <a:outerShdw sx="100000" sy="100000" kx="0" ky="0" algn="bl" rotWithShape="0" blurRad="101600" dist="25400" dir="5400000">
+              <a:srgbClr val="9AA3B2">
+                <a:alpha val="22000"/>
+              </a:srgbClr>
+            </a:outerShdw>
+          </a:effectLst>
         </p:spPr>
       </p:sp>
       <p:sp>
@@ -5693,7 +5728,7 @@
             <a:avLst/>
           </a:prstGeom>
           <a:solidFill>
-            <a:srgbClr val="E1348B"/>
+            <a:srgbClr val="DB2777"/>
           </a:solidFill>
           <a:ln/>
         </p:spPr>
@@ -5728,7 +5763,7 @@
             <a:r>
               <a:rPr lang="en-US" sz="1550" b="1" dirty="0">
                 <a:solidFill>
-                  <a:srgbClr val="F5F5F7"/>
+                  <a:srgbClr val="16171F"/>
                 </a:solidFill>
                 <a:latin typeface="Arial" pitchFamily="34" charset="0"/>
                 <a:ea typeface="Arial" pitchFamily="34" charset="-122"/>
@@ -5770,7 +5805,7 @@
             <a:r>
               <a:rPr lang="en-US" sz="1250" dirty="0">
                 <a:solidFill>
-                  <a:srgbClr val="9CA0AE"/>
+                  <a:srgbClr val="5C6472"/>
                 </a:solidFill>
                 <a:latin typeface="Calibri" pitchFamily="34" charset="0"/>
                 <a:ea typeface="Calibri" pitchFamily="34" charset="-122"/>
@@ -5799,14 +5834,21 @@
             </a:avLst>
           </a:prstGeom>
           <a:solidFill>
-            <a:srgbClr val="16161C"/>
+            <a:srgbClr val="FFFFFF"/>
           </a:solidFill>
           <a:ln w="12700">
             <a:solidFill>
-              <a:srgbClr val="24242E"/>
+              <a:srgbClr val="E4E7ED"/>
             </a:solidFill>
             <a:prstDash val="solid"/>
           </a:ln>
+          <a:effectLst>
+            <a:outerShdw sx="100000" sy="100000" kx="0" ky="0" algn="bl" rotWithShape="0" blurRad="101600" dist="25400" dir="5400000">
+              <a:srgbClr val="9AA3B2">
+                <a:alpha val="22000"/>
+              </a:srgbClr>
+            </a:outerShdw>
+          </a:effectLst>
         </p:spPr>
       </p:sp>
       <p:sp>
@@ -5824,7 +5866,7 @@
             <a:avLst/>
           </a:prstGeom>
           <a:solidFill>
-            <a:srgbClr val="F59E0B"/>
+            <a:srgbClr val="D97706"/>
           </a:solidFill>
           <a:ln/>
         </p:spPr>
@@ -5859,7 +5901,7 @@
             <a:r>
               <a:rPr lang="en-US" sz="1550" b="1" dirty="0">
                 <a:solidFill>
-                  <a:srgbClr val="F5F5F7"/>
+                  <a:srgbClr val="16171F"/>
                 </a:solidFill>
                 <a:latin typeface="Arial" pitchFamily="34" charset="0"/>
                 <a:ea typeface="Arial" pitchFamily="34" charset="-122"/>
@@ -5901,7 +5943,7 @@
             <a:r>
               <a:rPr lang="en-US" sz="1250" dirty="0">
                 <a:solidFill>
-                  <a:srgbClr val="9CA0AE"/>
+                  <a:srgbClr val="5C6472"/>
                 </a:solidFill>
                 <a:latin typeface="Calibri" pitchFamily="34" charset="0"/>
                 <a:ea typeface="Calibri" pitchFamily="34" charset="-122"/>
@@ -5927,7 +5969,7 @@
     <p:bg>
       <p:bgPr>
         <a:solidFill>
-          <a:srgbClr val="0B0B0F"/>
+          <a:srgbClr val="F7F8FA"/>
         </a:solidFill>
       </p:bgPr>
     </p:bg>
@@ -5960,7 +6002,7 @@
             <a:avLst/>
           </a:prstGeom>
           <a:solidFill>
-            <a:srgbClr val="8B5CF6"/>
+            <a:srgbClr val="6D28D9"/>
           </a:solidFill>
           <a:ln/>
         </p:spPr>
@@ -5992,7 +6034,7 @@
             <a:r>
               <a:rPr lang="en-US" sz="1100" b="1" spc="200" kern="0" dirty="0">
                 <a:solidFill>
-                  <a:srgbClr val="8B5CF6"/>
+                  <a:srgbClr val="6D28D9"/>
                 </a:solidFill>
                 <a:latin typeface="Courier New" pitchFamily="34" charset="0"/>
                 <a:ea typeface="Courier New" pitchFamily="34" charset="-122"/>
@@ -6034,7 +6076,7 @@
             <a:r>
               <a:rPr lang="en-US" sz="2900" b="1" dirty="0">
                 <a:solidFill>
-                  <a:srgbClr val="F5F5F7"/>
+                  <a:srgbClr val="16171F"/>
                 </a:solidFill>
                 <a:latin typeface="Arial" pitchFamily="34" charset="0"/>
                 <a:ea typeface="Arial" pitchFamily="34" charset="-122"/>
@@ -6073,7 +6115,7 @@
             <a:r>
               <a:rPr lang="en-US" sz="800" spc="200" kern="0" dirty="0">
                 <a:solidFill>
-                  <a:srgbClr val="6B7280"/>
+                  <a:srgbClr val="9AA0AC"/>
                 </a:solidFill>
                 <a:latin typeface="Courier New" pitchFamily="34" charset="0"/>
                 <a:ea typeface="Courier New" pitchFamily="34" charset="-122"/>
@@ -6112,7 +6154,7 @@
             <a:r>
               <a:rPr lang="en-US" sz="800" dirty="0">
                 <a:solidFill>
-                  <a:srgbClr val="6B7280"/>
+                  <a:srgbClr val="9AA0AC"/>
                 </a:solidFill>
                 <a:latin typeface="Courier New" pitchFamily="34" charset="0"/>
                 <a:ea typeface="Courier New" pitchFamily="34" charset="-122"/>
@@ -6141,14 +6183,21 @@
             </a:avLst>
           </a:prstGeom>
           <a:solidFill>
-            <a:srgbClr val="16161C"/>
+            <a:srgbClr val="FFFFFF"/>
           </a:solidFill>
           <a:ln w="12700">
             <a:solidFill>
-              <a:srgbClr val="24242E"/>
+              <a:srgbClr val="E4E7ED"/>
             </a:solidFill>
             <a:prstDash val="solid"/>
           </a:ln>
+          <a:effectLst>
+            <a:outerShdw sx="100000" sy="100000" kx="0" ky="0" algn="bl" rotWithShape="0" blurRad="101600" dist="25400" dir="5400000">
+              <a:srgbClr val="9AA3B2">
+                <a:alpha val="22000"/>
+              </a:srgbClr>
+            </a:outerShdw>
+          </a:effectLst>
         </p:spPr>
       </p:sp>
       <p:sp>
@@ -6178,7 +6227,7 @@
             <a:r>
               <a:rPr lang="en-US" sz="1500" b="1" dirty="0">
                 <a:solidFill>
-                  <a:srgbClr val="8B5CF6"/>
+                  <a:srgbClr val="6D28D9"/>
                 </a:solidFill>
                 <a:latin typeface="Courier New" pitchFamily="34" charset="0"/>
                 <a:ea typeface="Courier New" pitchFamily="34" charset="-122"/>
@@ -6217,7 +6266,7 @@
             <a:r>
               <a:rPr lang="en-US" sz="1600" b="1" dirty="0">
                 <a:solidFill>
-                  <a:srgbClr val="F5F5F7"/>
+                  <a:srgbClr val="16171F"/>
                 </a:solidFill>
                 <a:latin typeface="Arial" pitchFamily="34" charset="0"/>
                 <a:ea typeface="Arial" pitchFamily="34" charset="-122"/>
@@ -6259,7 +6308,7 @@
             <a:r>
               <a:rPr lang="en-US" sz="1250" dirty="0">
                 <a:solidFill>
-                  <a:srgbClr val="9CA0AE"/>
+                  <a:srgbClr val="5C6472"/>
                 </a:solidFill>
                 <a:latin typeface="Calibri" pitchFamily="34" charset="0"/>
                 <a:ea typeface="Calibri" pitchFamily="34" charset="-122"/>
@@ -6288,14 +6337,21 @@
             </a:avLst>
           </a:prstGeom>
           <a:solidFill>
-            <a:srgbClr val="16161C"/>
+            <a:srgbClr val="FFFFFF"/>
           </a:solidFill>
           <a:ln w="12700">
             <a:solidFill>
-              <a:srgbClr val="24242E"/>
+              <a:srgbClr val="E4E7ED"/>
             </a:solidFill>
             <a:prstDash val="solid"/>
           </a:ln>
+          <a:effectLst>
+            <a:outerShdw sx="100000" sy="100000" kx="0" ky="0" algn="bl" rotWithShape="0" blurRad="101600" dist="25400" dir="5400000">
+              <a:srgbClr val="9AA3B2">
+                <a:alpha val="22000"/>
+              </a:srgbClr>
+            </a:outerShdw>
+          </a:effectLst>
         </p:spPr>
       </p:sp>
       <p:sp>
@@ -6325,7 +6381,7 @@
             <a:r>
               <a:rPr lang="en-US" sz="1500" b="1" dirty="0">
                 <a:solidFill>
-                  <a:srgbClr val="8B5CF6"/>
+                  <a:srgbClr val="6D28D9"/>
                 </a:solidFill>
                 <a:latin typeface="Courier New" pitchFamily="34" charset="0"/>
                 <a:ea typeface="Courier New" pitchFamily="34" charset="-122"/>
@@ -6364,7 +6420,7 @@
             <a:r>
               <a:rPr lang="en-US" sz="1600" b="1" dirty="0">
                 <a:solidFill>
-                  <a:srgbClr val="F5F5F7"/>
+                  <a:srgbClr val="16171F"/>
                 </a:solidFill>
                 <a:latin typeface="Arial" pitchFamily="34" charset="0"/>
                 <a:ea typeface="Arial" pitchFamily="34" charset="-122"/>
@@ -6406,7 +6462,7 @@
             <a:r>
               <a:rPr lang="en-US" sz="1250" dirty="0">
                 <a:solidFill>
-                  <a:srgbClr val="9CA0AE"/>
+                  <a:srgbClr val="5C6472"/>
                 </a:solidFill>
                 <a:latin typeface="Calibri" pitchFamily="34" charset="0"/>
                 <a:ea typeface="Calibri" pitchFamily="34" charset="-122"/>
@@ -6435,14 +6491,21 @@
             </a:avLst>
           </a:prstGeom>
           <a:solidFill>
-            <a:srgbClr val="16161C"/>
+            <a:srgbClr val="FFFFFF"/>
           </a:solidFill>
           <a:ln w="12700">
             <a:solidFill>
-              <a:srgbClr val="24242E"/>
+              <a:srgbClr val="E4E7ED"/>
             </a:solidFill>
             <a:prstDash val="solid"/>
           </a:ln>
+          <a:effectLst>
+            <a:outerShdw sx="100000" sy="100000" kx="0" ky="0" algn="bl" rotWithShape="0" blurRad="101600" dist="25400" dir="5400000">
+              <a:srgbClr val="9AA3B2">
+                <a:alpha val="22000"/>
+              </a:srgbClr>
+            </a:outerShdw>
+          </a:effectLst>
         </p:spPr>
       </p:sp>
       <p:sp>
@@ -6472,7 +6535,7 @@
             <a:r>
               <a:rPr lang="en-US" sz="1500" b="1" dirty="0">
                 <a:solidFill>
-                  <a:srgbClr val="8B5CF6"/>
+                  <a:srgbClr val="6D28D9"/>
                 </a:solidFill>
                 <a:latin typeface="Courier New" pitchFamily="34" charset="0"/>
                 <a:ea typeface="Courier New" pitchFamily="34" charset="-122"/>
@@ -6511,7 +6574,7 @@
             <a:r>
               <a:rPr lang="en-US" sz="1600" b="1" dirty="0">
                 <a:solidFill>
-                  <a:srgbClr val="F5F5F7"/>
+                  <a:srgbClr val="16171F"/>
                 </a:solidFill>
                 <a:latin typeface="Arial" pitchFamily="34" charset="0"/>
                 <a:ea typeface="Arial" pitchFamily="34" charset="-122"/>
@@ -6553,7 +6616,7 @@
             <a:r>
               <a:rPr lang="en-US" sz="1250" dirty="0">
                 <a:solidFill>
-                  <a:srgbClr val="9CA0AE"/>
+                  <a:srgbClr val="5C6472"/>
                 </a:solidFill>
                 <a:latin typeface="Calibri" pitchFamily="34" charset="0"/>
                 <a:ea typeface="Calibri" pitchFamily="34" charset="-122"/>
@@ -6582,14 +6645,21 @@
             </a:avLst>
           </a:prstGeom>
           <a:solidFill>
-            <a:srgbClr val="16161C"/>
+            <a:srgbClr val="FFFFFF"/>
           </a:solidFill>
           <a:ln w="12700">
             <a:solidFill>
-              <a:srgbClr val="24242E"/>
+              <a:srgbClr val="E4E7ED"/>
             </a:solidFill>
             <a:prstDash val="solid"/>
           </a:ln>
+          <a:effectLst>
+            <a:outerShdw sx="100000" sy="100000" kx="0" ky="0" algn="bl" rotWithShape="0" blurRad="101600" dist="25400" dir="5400000">
+              <a:srgbClr val="9AA3B2">
+                <a:alpha val="22000"/>
+              </a:srgbClr>
+            </a:outerShdw>
+          </a:effectLst>
         </p:spPr>
       </p:sp>
       <p:sp>
@@ -6619,7 +6689,7 @@
             <a:r>
               <a:rPr lang="en-US" sz="1500" b="1" dirty="0">
                 <a:solidFill>
-                  <a:srgbClr val="8B5CF6"/>
+                  <a:srgbClr val="6D28D9"/>
                 </a:solidFill>
                 <a:latin typeface="Courier New" pitchFamily="34" charset="0"/>
                 <a:ea typeface="Courier New" pitchFamily="34" charset="-122"/>
@@ -6658,7 +6728,7 @@
             <a:r>
               <a:rPr lang="en-US" sz="1600" b="1" dirty="0">
                 <a:solidFill>
-                  <a:srgbClr val="F5F5F7"/>
+                  <a:srgbClr val="16171F"/>
                 </a:solidFill>
                 <a:latin typeface="Arial" pitchFamily="34" charset="0"/>
                 <a:ea typeface="Arial" pitchFamily="34" charset="-122"/>
@@ -6700,7 +6770,7 @@
             <a:r>
               <a:rPr lang="en-US" sz="1250" dirty="0">
                 <a:solidFill>
-                  <a:srgbClr val="9CA0AE"/>
+                  <a:srgbClr val="5C6472"/>
                 </a:solidFill>
                 <a:latin typeface="Calibri" pitchFamily="34" charset="0"/>
                 <a:ea typeface="Calibri" pitchFamily="34" charset="-122"/>
@@ -6726,7 +6796,7 @@
     <p:bg>
       <p:bgPr>
         <a:solidFill>
-          <a:srgbClr val="0B0B0F"/>
+          <a:srgbClr val="F7F8FA"/>
         </a:solidFill>
       </p:bgPr>
     </p:bg>
@@ -6759,7 +6829,7 @@
             <a:avLst/>
           </a:prstGeom>
           <a:solidFill>
-            <a:srgbClr val="8B5CF6"/>
+            <a:srgbClr val="6D28D9"/>
           </a:solidFill>
           <a:ln/>
         </p:spPr>
@@ -6791,7 +6861,7 @@
             <a:r>
               <a:rPr lang="en-US" sz="1100" b="1" spc="200" kern="0" dirty="0">
                 <a:solidFill>
-                  <a:srgbClr val="8B5CF6"/>
+                  <a:srgbClr val="6D28D9"/>
                 </a:solidFill>
                 <a:latin typeface="Courier New" pitchFamily="34" charset="0"/>
                 <a:ea typeface="Courier New" pitchFamily="34" charset="-122"/>
@@ -6833,7 +6903,7 @@
             <a:r>
               <a:rPr lang="en-US" sz="2900" b="1" dirty="0">
                 <a:solidFill>
-                  <a:srgbClr val="F5F5F7"/>
+                  <a:srgbClr val="16171F"/>
                 </a:solidFill>
                 <a:latin typeface="Arial" pitchFamily="34" charset="0"/>
                 <a:ea typeface="Arial" pitchFamily="34" charset="-122"/>
@@ -6872,7 +6942,7 @@
             <a:r>
               <a:rPr lang="en-US" sz="800" spc="200" kern="0" dirty="0">
                 <a:solidFill>
-                  <a:srgbClr val="6B7280"/>
+                  <a:srgbClr val="9AA0AC"/>
                 </a:solidFill>
                 <a:latin typeface="Courier New" pitchFamily="34" charset="0"/>
                 <a:ea typeface="Courier New" pitchFamily="34" charset="-122"/>
@@ -6911,7 +6981,7 @@
             <a:r>
               <a:rPr lang="en-US" sz="800" dirty="0">
                 <a:solidFill>
-                  <a:srgbClr val="6B7280"/>
+                  <a:srgbClr val="9AA0AC"/>
                 </a:solidFill>
                 <a:latin typeface="Courier New" pitchFamily="34" charset="0"/>
                 <a:ea typeface="Courier New" pitchFamily="34" charset="-122"/>
@@ -6953,7 +7023,7 @@
             <a:r>
               <a:rPr lang="en-US" sz="1550" dirty="0">
                 <a:solidFill>
-                  <a:srgbClr val="9CA0AE"/>
+                  <a:srgbClr val="5C6472"/>
                 </a:solidFill>
                 <a:latin typeface="Calibri" pitchFamily="34" charset="0"/>
                 <a:ea typeface="Calibri" pitchFamily="34" charset="-122"/>
@@ -6982,11 +7052,11 @@
             </a:avLst>
           </a:prstGeom>
           <a:solidFill>
-            <a:srgbClr val="16161C"/>
+            <a:srgbClr val="FFFFFF"/>
           </a:solidFill>
           <a:ln w="12700">
             <a:solidFill>
-              <a:srgbClr val="8B5CF6"/>
+              <a:srgbClr val="6D28D9"/>
             </a:solidFill>
             <a:prstDash val="solid"/>
           </a:ln>
@@ -7019,7 +7089,7 @@
             <a:r>
               <a:rPr lang="en-US" sz="1050" spc="100" kern="0" dirty="0">
                 <a:solidFill>
-                  <a:srgbClr val="F5F5F7"/>
+                  <a:srgbClr val="16171F"/>
                 </a:solidFill>
                 <a:latin typeface="Courier New" pitchFamily="34" charset="0"/>
                 <a:ea typeface="Courier New" pitchFamily="34" charset="-122"/>
@@ -7048,11 +7118,11 @@
             </a:avLst>
           </a:prstGeom>
           <a:solidFill>
-            <a:srgbClr val="16161C"/>
+            <a:srgbClr val="FFFFFF"/>
           </a:solidFill>
           <a:ln w="12700">
             <a:solidFill>
-              <a:srgbClr val="E1348B"/>
+              <a:srgbClr val="DB2777"/>
             </a:solidFill>
             <a:prstDash val="solid"/>
           </a:ln>
@@ -7085,7 +7155,7 @@
             <a:r>
               <a:rPr lang="en-US" sz="1050" spc="100" kern="0" dirty="0">
                 <a:solidFill>
-                  <a:srgbClr val="F5F5F7"/>
+                  <a:srgbClr val="16171F"/>
                 </a:solidFill>
                 <a:latin typeface="Courier New" pitchFamily="34" charset="0"/>
                 <a:ea typeface="Courier New" pitchFamily="34" charset="-122"/>
@@ -7114,11 +7184,11 @@
             </a:avLst>
           </a:prstGeom>
           <a:solidFill>
-            <a:srgbClr val="16161C"/>
+            <a:srgbClr val="FFFFFF"/>
           </a:solidFill>
           <a:ln w="12700">
             <a:solidFill>
-              <a:srgbClr val="10B981"/>
+              <a:srgbClr val="059669"/>
             </a:solidFill>
             <a:prstDash val="solid"/>
           </a:ln>
@@ -7151,7 +7221,7 @@
             <a:r>
               <a:rPr lang="en-US" sz="1050" spc="100" kern="0" dirty="0">
                 <a:solidFill>
-                  <a:srgbClr val="F5F5F7"/>
+                  <a:srgbClr val="16171F"/>
                 </a:solidFill>
                 <a:latin typeface="Courier New" pitchFamily="34" charset="0"/>
                 <a:ea typeface="Courier New" pitchFamily="34" charset="-122"/>
@@ -7180,11 +7250,11 @@
             </a:avLst>
           </a:prstGeom>
           <a:solidFill>
-            <a:srgbClr val="16161C"/>
+            <a:srgbClr val="FFFFFF"/>
           </a:solidFill>
           <a:ln w="12700">
             <a:solidFill>
-              <a:srgbClr val="F59E0B"/>
+              <a:srgbClr val="D97706"/>
             </a:solidFill>
             <a:prstDash val="solid"/>
           </a:ln>
@@ -7217,7 +7287,7 @@
             <a:r>
               <a:rPr lang="en-US" sz="1050" spc="100" kern="0" dirty="0">
                 <a:solidFill>
-                  <a:srgbClr val="F5F5F7"/>
+                  <a:srgbClr val="16171F"/>
                 </a:solidFill>
                 <a:latin typeface="Courier New" pitchFamily="34" charset="0"/>
                 <a:ea typeface="Courier New" pitchFamily="34" charset="-122"/>
@@ -7246,11 +7316,11 @@
             </a:avLst>
           </a:prstGeom>
           <a:solidFill>
-            <a:srgbClr val="16161C"/>
+            <a:srgbClr val="FFFFFF"/>
           </a:solidFill>
           <a:ln w="12700">
             <a:solidFill>
-              <a:srgbClr val="8B5CF6"/>
+              <a:srgbClr val="6D28D9"/>
             </a:solidFill>
             <a:prstDash val="solid"/>
           </a:ln>
@@ -7283,7 +7353,7 @@
             <a:r>
               <a:rPr lang="en-US" sz="1050" spc="100" kern="0" dirty="0">
                 <a:solidFill>
-                  <a:srgbClr val="F5F5F7"/>
+                  <a:srgbClr val="16171F"/>
                 </a:solidFill>
                 <a:latin typeface="Courier New" pitchFamily="34" charset="0"/>
                 <a:ea typeface="Courier New" pitchFamily="34" charset="-122"/>
@@ -7312,14 +7382,21 @@
             </a:avLst>
           </a:prstGeom>
           <a:solidFill>
-            <a:srgbClr val="16161C"/>
+            <a:srgbClr val="FFFFFF"/>
           </a:solidFill>
           <a:ln w="12700">
             <a:solidFill>
-              <a:srgbClr val="24242E"/>
+              <a:srgbClr val="E4E7ED"/>
             </a:solidFill>
             <a:prstDash val="solid"/>
           </a:ln>
+          <a:effectLst>
+            <a:outerShdw sx="100000" sy="100000" kx="0" ky="0" algn="bl" rotWithShape="0" blurRad="101600" dist="25400" dir="5400000">
+              <a:srgbClr val="9AA3B2">
+                <a:alpha val="22000"/>
+              </a:srgbClr>
+            </a:outerShdw>
+          </a:effectLst>
         </p:spPr>
       </p:sp>
       <p:sp>
@@ -7349,7 +7426,7 @@
             <a:r>
               <a:rPr lang="en-US" sz="3400" b="1" dirty="0">
                 <a:solidFill>
-                  <a:srgbClr val="F5F5F7"/>
+                  <a:srgbClr val="16171F"/>
                 </a:solidFill>
                 <a:latin typeface="Arial" pitchFamily="34" charset="0"/>
                 <a:ea typeface="Arial" pitchFamily="34" charset="-122"/>
@@ -7388,7 +7465,7 @@
             <a:r>
               <a:rPr lang="en-US" sz="1050" spc="100" kern="0" dirty="0">
                 <a:solidFill>
-                  <a:srgbClr val="9CA0AE"/>
+                  <a:srgbClr val="5C6472"/>
                 </a:solidFill>
                 <a:latin typeface="Courier New" pitchFamily="34" charset="0"/>
                 <a:ea typeface="Courier New" pitchFamily="34" charset="-122"/>
@@ -7417,14 +7494,21 @@
             </a:avLst>
           </a:prstGeom>
           <a:solidFill>
-            <a:srgbClr val="16161C"/>
+            <a:srgbClr val="FFFFFF"/>
           </a:solidFill>
           <a:ln w="12700">
             <a:solidFill>
-              <a:srgbClr val="24242E"/>
+              <a:srgbClr val="E4E7ED"/>
             </a:solidFill>
             <a:prstDash val="solid"/>
           </a:ln>
+          <a:effectLst>
+            <a:outerShdw sx="100000" sy="100000" kx="0" ky="0" algn="bl" rotWithShape="0" blurRad="101600" dist="25400" dir="5400000">
+              <a:srgbClr val="9AA3B2">
+                <a:alpha val="22000"/>
+              </a:srgbClr>
+            </a:outerShdw>
+          </a:effectLst>
         </p:spPr>
       </p:sp>
       <p:sp>
@@ -7454,7 +7538,7 @@
             <a:r>
               <a:rPr lang="en-US" sz="3400" b="1" dirty="0">
                 <a:solidFill>
-                  <a:srgbClr val="F5F5F7"/>
+                  <a:srgbClr val="16171F"/>
                 </a:solidFill>
                 <a:latin typeface="Arial" pitchFamily="34" charset="0"/>
                 <a:ea typeface="Arial" pitchFamily="34" charset="-122"/>
@@ -7493,7 +7577,7 @@
             <a:r>
               <a:rPr lang="en-US" sz="1050" spc="100" kern="0" dirty="0">
                 <a:solidFill>
-                  <a:srgbClr val="9CA0AE"/>
+                  <a:srgbClr val="5C6472"/>
                 </a:solidFill>
                 <a:latin typeface="Courier New" pitchFamily="34" charset="0"/>
                 <a:ea typeface="Courier New" pitchFamily="34" charset="-122"/>
@@ -7522,14 +7606,21 @@
             </a:avLst>
           </a:prstGeom>
           <a:solidFill>
-            <a:srgbClr val="16161C"/>
+            <a:srgbClr val="FFFFFF"/>
           </a:solidFill>
           <a:ln w="12700">
             <a:solidFill>
-              <a:srgbClr val="24242E"/>
+              <a:srgbClr val="E4E7ED"/>
             </a:solidFill>
             <a:prstDash val="solid"/>
           </a:ln>
+          <a:effectLst>
+            <a:outerShdw sx="100000" sy="100000" kx="0" ky="0" algn="bl" rotWithShape="0" blurRad="101600" dist="25400" dir="5400000">
+              <a:srgbClr val="9AA3B2">
+                <a:alpha val="22000"/>
+              </a:srgbClr>
+            </a:outerShdw>
+          </a:effectLst>
         </p:spPr>
       </p:sp>
       <p:sp>
@@ -7559,7 +7650,7 @@
             <a:r>
               <a:rPr lang="en-US" sz="3400" b="1" dirty="0">
                 <a:solidFill>
-                  <a:srgbClr val="F5F5F7"/>
+                  <a:srgbClr val="16171F"/>
                 </a:solidFill>
                 <a:latin typeface="Arial" pitchFamily="34" charset="0"/>
                 <a:ea typeface="Arial" pitchFamily="34" charset="-122"/>
@@ -7598,7 +7689,7 @@
             <a:r>
               <a:rPr lang="en-US" sz="1050" spc="100" kern="0" dirty="0">
                 <a:solidFill>
-                  <a:srgbClr val="9CA0AE"/>
+                  <a:srgbClr val="5C6472"/>
                 </a:solidFill>
                 <a:latin typeface="Courier New" pitchFamily="34" charset="0"/>
                 <a:ea typeface="Courier New" pitchFamily="34" charset="-122"/>
@@ -7624,7 +7715,7 @@
     <p:bg>
       <p:bgPr>
         <a:solidFill>
-          <a:srgbClr val="0B0B0F"/>
+          <a:srgbClr val="F7F8FA"/>
         </a:solidFill>
       </p:bgPr>
     </p:bg>
@@ -7657,7 +7748,7 @@
             <a:avLst/>
           </a:prstGeom>
           <a:solidFill>
-            <a:srgbClr val="8B5CF6"/>
+            <a:srgbClr val="6D28D9"/>
           </a:solidFill>
           <a:ln/>
         </p:spPr>
@@ -7689,7 +7780,7 @@
             <a:r>
               <a:rPr lang="en-US" sz="1100" b="1" spc="200" kern="0" dirty="0">
                 <a:solidFill>
-                  <a:srgbClr val="8B5CF6"/>
+                  <a:srgbClr val="6D28D9"/>
                 </a:solidFill>
                 <a:latin typeface="Courier New" pitchFamily="34" charset="0"/>
                 <a:ea typeface="Courier New" pitchFamily="34" charset="-122"/>
@@ -7731,7 +7822,7 @@
             <a:r>
               <a:rPr lang="en-US" sz="2900" b="1" dirty="0">
                 <a:solidFill>
-                  <a:srgbClr val="F5F5F7"/>
+                  <a:srgbClr val="16171F"/>
                 </a:solidFill>
                 <a:latin typeface="Arial" pitchFamily="34" charset="0"/>
                 <a:ea typeface="Arial" pitchFamily="34" charset="-122"/>
@@ -7770,7 +7861,7 @@
             <a:r>
               <a:rPr lang="en-US" sz="800" spc="200" kern="0" dirty="0">
                 <a:solidFill>
-                  <a:srgbClr val="6B7280"/>
+                  <a:srgbClr val="9AA0AC"/>
                 </a:solidFill>
                 <a:latin typeface="Courier New" pitchFamily="34" charset="0"/>
                 <a:ea typeface="Courier New" pitchFamily="34" charset="-122"/>
@@ -7809,7 +7900,7 @@
             <a:r>
               <a:rPr lang="en-US" sz="800" dirty="0">
                 <a:solidFill>
-                  <a:srgbClr val="6B7280"/>
+                  <a:srgbClr val="9AA0AC"/>
                 </a:solidFill>
                 <a:latin typeface="Courier New" pitchFamily="34" charset="0"/>
                 <a:ea typeface="Courier New" pitchFamily="34" charset="-122"/>
@@ -7838,14 +7929,21 @@
             </a:avLst>
           </a:prstGeom>
           <a:solidFill>
-            <a:srgbClr val="16161C"/>
+            <a:srgbClr val="FFFFFF"/>
           </a:solidFill>
           <a:ln w="12700">
             <a:solidFill>
-              <a:srgbClr val="24242E"/>
+              <a:srgbClr val="E4E7ED"/>
             </a:solidFill>
             <a:prstDash val="solid"/>
           </a:ln>
+          <a:effectLst>
+            <a:outerShdw sx="100000" sy="100000" kx="0" ky="0" algn="bl" rotWithShape="0" blurRad="101600" dist="25400" dir="5400000">
+              <a:srgbClr val="9AA3B2">
+                <a:alpha val="22000"/>
+              </a:srgbClr>
+            </a:outerShdw>
+          </a:effectLst>
         </p:spPr>
       </p:sp>
       <p:sp>
@@ -7865,11 +7963,11 @@
             </a:avLst>
           </a:prstGeom>
           <a:solidFill>
-            <a:srgbClr val="0E0E15"/>
+            <a:srgbClr val="F1ECFD"/>
           </a:solidFill>
           <a:ln w="15875">
             <a:solidFill>
-              <a:srgbClr val="8B5CF6"/>
+              <a:srgbClr val="6D28D9"/>
             </a:solidFill>
             <a:prstDash val="solid"/>
           </a:ln>
@@ -7902,7 +8000,7 @@
             <a:r>
               <a:rPr lang="en-US" sz="1600" b="1" dirty="0">
                 <a:solidFill>
-                  <a:srgbClr val="8B5CF6"/>
+                  <a:srgbClr val="6D28D9"/>
                 </a:solidFill>
                 <a:latin typeface="Courier New" pitchFamily="34" charset="0"/>
                 <a:ea typeface="Courier New" pitchFamily="34" charset="-122"/>
@@ -7941,7 +8039,7 @@
             <a:r>
               <a:rPr lang="en-US" sz="1400" b="1" dirty="0">
                 <a:solidFill>
-                  <a:srgbClr val="F5F5F7"/>
+                  <a:srgbClr val="16171F"/>
                 </a:solidFill>
                 <a:latin typeface="Arial" pitchFamily="34" charset="0"/>
                 <a:ea typeface="Arial" pitchFamily="34" charset="-122"/>
@@ -7980,7 +8078,7 @@
             <a:r>
               <a:rPr lang="en-US" sz="1050" dirty="0">
                 <a:solidFill>
-                  <a:srgbClr val="9CA0AE"/>
+                  <a:srgbClr val="5C6472"/>
                 </a:solidFill>
                 <a:latin typeface="Calibri" pitchFamily="34" charset="0"/>
                 <a:ea typeface="Calibri" pitchFamily="34" charset="-122"/>
@@ -8019,7 +8117,7 @@
             <a:r>
               <a:rPr lang="en-US" sz="1800" dirty="0">
                 <a:solidFill>
-                  <a:srgbClr val="6B7280"/>
+                  <a:srgbClr val="9AA0AC"/>
                 </a:solidFill>
                 <a:latin typeface="Arial" pitchFamily="34" charset="0"/>
                 <a:ea typeface="Arial" pitchFamily="34" charset="-122"/>
@@ -8048,14 +8146,21 @@
             </a:avLst>
           </a:prstGeom>
           <a:solidFill>
-            <a:srgbClr val="16161C"/>
+            <a:srgbClr val="FFFFFF"/>
           </a:solidFill>
           <a:ln w="12700">
             <a:solidFill>
-              <a:srgbClr val="24242E"/>
+              <a:srgbClr val="E4E7ED"/>
             </a:solidFill>
             <a:prstDash val="solid"/>
           </a:ln>
+          <a:effectLst>
+            <a:outerShdw sx="100000" sy="100000" kx="0" ky="0" algn="bl" rotWithShape="0" blurRad="101600" dist="25400" dir="5400000">
+              <a:srgbClr val="9AA3B2">
+                <a:alpha val="22000"/>
+              </a:srgbClr>
+            </a:outerShdw>
+          </a:effectLst>
         </p:spPr>
       </p:sp>
       <p:sp>
@@ -8075,11 +8180,11 @@
             </a:avLst>
           </a:prstGeom>
           <a:solidFill>
-            <a:srgbClr val="0E0E15"/>
+            <a:srgbClr val="F1ECFD"/>
           </a:solidFill>
           <a:ln w="15875">
             <a:solidFill>
-              <a:srgbClr val="8B5CF6"/>
+              <a:srgbClr val="6D28D9"/>
             </a:solidFill>
             <a:prstDash val="solid"/>
           </a:ln>
@@ -8112,7 +8217,7 @@
             <a:r>
               <a:rPr lang="en-US" sz="1600" b="1" dirty="0">
                 <a:solidFill>
-                  <a:srgbClr val="8B5CF6"/>
+                  <a:srgbClr val="6D28D9"/>
                 </a:solidFill>
                 <a:latin typeface="Courier New" pitchFamily="34" charset="0"/>
                 <a:ea typeface="Courier New" pitchFamily="34" charset="-122"/>
@@ -8151,7 +8256,7 @@
             <a:r>
               <a:rPr lang="en-US" sz="1400" b="1" dirty="0">
                 <a:solidFill>
-                  <a:srgbClr val="F5F5F7"/>
+                  <a:srgbClr val="16171F"/>
                 </a:solidFill>
                 <a:latin typeface="Arial" pitchFamily="34" charset="0"/>
                 <a:ea typeface="Arial" pitchFamily="34" charset="-122"/>
@@ -8190,7 +8295,7 @@
             <a:r>
               <a:rPr lang="en-US" sz="1050" dirty="0">
                 <a:solidFill>
-                  <a:srgbClr val="9CA0AE"/>
+                  <a:srgbClr val="5C6472"/>
                 </a:solidFill>
                 <a:latin typeface="Calibri" pitchFamily="34" charset="0"/>
                 <a:ea typeface="Calibri" pitchFamily="34" charset="-122"/>
@@ -8229,7 +8334,7 @@
             <a:r>
               <a:rPr lang="en-US" sz="1800" dirty="0">
                 <a:solidFill>
-                  <a:srgbClr val="6B7280"/>
+                  <a:srgbClr val="9AA0AC"/>
                 </a:solidFill>
                 <a:latin typeface="Arial" pitchFamily="34" charset="0"/>
                 <a:ea typeface="Arial" pitchFamily="34" charset="-122"/>
@@ -8258,14 +8363,21 @@
             </a:avLst>
           </a:prstGeom>
           <a:solidFill>
-            <a:srgbClr val="16161C"/>
+            <a:srgbClr val="FFFFFF"/>
           </a:solidFill>
           <a:ln w="12700">
             <a:solidFill>
-              <a:srgbClr val="24242E"/>
+              <a:srgbClr val="E4E7ED"/>
             </a:solidFill>
             <a:prstDash val="solid"/>
           </a:ln>
+          <a:effectLst>
+            <a:outerShdw sx="100000" sy="100000" kx="0" ky="0" algn="bl" rotWithShape="0" blurRad="101600" dist="25400" dir="5400000">
+              <a:srgbClr val="9AA3B2">
+                <a:alpha val="22000"/>
+              </a:srgbClr>
+            </a:outerShdw>
+          </a:effectLst>
         </p:spPr>
       </p:sp>
       <p:sp>
@@ -8285,11 +8397,11 @@
             </a:avLst>
           </a:prstGeom>
           <a:solidFill>
-            <a:srgbClr val="0E0E15"/>
+            <a:srgbClr val="F1ECFD"/>
           </a:solidFill>
           <a:ln w="15875">
             <a:solidFill>
-              <a:srgbClr val="8B5CF6"/>
+              <a:srgbClr val="6D28D9"/>
             </a:solidFill>
             <a:prstDash val="solid"/>
           </a:ln>
@@ -8322,7 +8434,7 @@
             <a:r>
               <a:rPr lang="en-US" sz="1600" b="1" dirty="0">
                 <a:solidFill>
-                  <a:srgbClr val="8B5CF6"/>
+                  <a:srgbClr val="6D28D9"/>
                 </a:solidFill>
                 <a:latin typeface="Courier New" pitchFamily="34" charset="0"/>
                 <a:ea typeface="Courier New" pitchFamily="34" charset="-122"/>
@@ -8361,7 +8473,7 @@
             <a:r>
               <a:rPr lang="en-US" sz="1400" b="1" dirty="0">
                 <a:solidFill>
-                  <a:srgbClr val="F5F5F7"/>
+                  <a:srgbClr val="16171F"/>
                 </a:solidFill>
                 <a:latin typeface="Arial" pitchFamily="34" charset="0"/>
                 <a:ea typeface="Arial" pitchFamily="34" charset="-122"/>
@@ -8400,7 +8512,7 @@
             <a:r>
               <a:rPr lang="en-US" sz="1050" dirty="0">
                 <a:solidFill>
-                  <a:srgbClr val="9CA0AE"/>
+                  <a:srgbClr val="5C6472"/>
                 </a:solidFill>
                 <a:latin typeface="Calibri" pitchFamily="34" charset="0"/>
                 <a:ea typeface="Calibri" pitchFamily="34" charset="-122"/>
@@ -8439,7 +8551,7 @@
             <a:r>
               <a:rPr lang="en-US" sz="1800" dirty="0">
                 <a:solidFill>
-                  <a:srgbClr val="6B7280"/>
+                  <a:srgbClr val="9AA0AC"/>
                 </a:solidFill>
                 <a:latin typeface="Arial" pitchFamily="34" charset="0"/>
                 <a:ea typeface="Arial" pitchFamily="34" charset="-122"/>
@@ -8468,14 +8580,21 @@
             </a:avLst>
           </a:prstGeom>
           <a:solidFill>
-            <a:srgbClr val="16161C"/>
+            <a:srgbClr val="FFFFFF"/>
           </a:solidFill>
           <a:ln w="12700">
             <a:solidFill>
-              <a:srgbClr val="24242E"/>
+              <a:srgbClr val="E4E7ED"/>
             </a:solidFill>
             <a:prstDash val="solid"/>
           </a:ln>
+          <a:effectLst>
+            <a:outerShdw sx="100000" sy="100000" kx="0" ky="0" algn="bl" rotWithShape="0" blurRad="101600" dist="25400" dir="5400000">
+              <a:srgbClr val="9AA3B2">
+                <a:alpha val="22000"/>
+              </a:srgbClr>
+            </a:outerShdw>
+          </a:effectLst>
         </p:spPr>
       </p:sp>
       <p:sp>
@@ -8495,11 +8614,11 @@
             </a:avLst>
           </a:prstGeom>
           <a:solidFill>
-            <a:srgbClr val="0E0E15"/>
+            <a:srgbClr val="F1ECFD"/>
           </a:solidFill>
           <a:ln w="15875">
             <a:solidFill>
-              <a:srgbClr val="8B5CF6"/>
+              <a:srgbClr val="6D28D9"/>
             </a:solidFill>
             <a:prstDash val="solid"/>
           </a:ln>
@@ -8532,7 +8651,7 @@
             <a:r>
               <a:rPr lang="en-US" sz="1600" b="1" dirty="0">
                 <a:solidFill>
-                  <a:srgbClr val="8B5CF6"/>
+                  <a:srgbClr val="6D28D9"/>
                 </a:solidFill>
                 <a:latin typeface="Courier New" pitchFamily="34" charset="0"/>
                 <a:ea typeface="Courier New" pitchFamily="34" charset="-122"/>
@@ -8571,7 +8690,7 @@
             <a:r>
               <a:rPr lang="en-US" sz="1400" b="1" dirty="0">
                 <a:solidFill>
-                  <a:srgbClr val="F5F5F7"/>
+                  <a:srgbClr val="16171F"/>
                 </a:solidFill>
                 <a:latin typeface="Arial" pitchFamily="34" charset="0"/>
                 <a:ea typeface="Arial" pitchFamily="34" charset="-122"/>
@@ -8610,7 +8729,7 @@
             <a:r>
               <a:rPr lang="en-US" sz="1050" dirty="0">
                 <a:solidFill>
-                  <a:srgbClr val="9CA0AE"/>
+                  <a:srgbClr val="5C6472"/>
                 </a:solidFill>
                 <a:latin typeface="Calibri" pitchFamily="34" charset="0"/>
                 <a:ea typeface="Calibri" pitchFamily="34" charset="-122"/>
@@ -8649,7 +8768,7 @@
             <a:r>
               <a:rPr lang="en-US" sz="1800" dirty="0">
                 <a:solidFill>
-                  <a:srgbClr val="6B7280"/>
+                  <a:srgbClr val="9AA0AC"/>
                 </a:solidFill>
                 <a:latin typeface="Arial" pitchFamily="34" charset="0"/>
                 <a:ea typeface="Arial" pitchFamily="34" charset="-122"/>
@@ -8678,14 +8797,21 @@
             </a:avLst>
           </a:prstGeom>
           <a:solidFill>
-            <a:srgbClr val="16161C"/>
+            <a:srgbClr val="FFFFFF"/>
           </a:solidFill>
           <a:ln w="12700">
             <a:solidFill>
-              <a:srgbClr val="24242E"/>
+              <a:srgbClr val="E4E7ED"/>
             </a:solidFill>
             <a:prstDash val="solid"/>
           </a:ln>
+          <a:effectLst>
+            <a:outerShdw sx="100000" sy="100000" kx="0" ky="0" algn="bl" rotWithShape="0" blurRad="101600" dist="25400" dir="5400000">
+              <a:srgbClr val="9AA3B2">
+                <a:alpha val="22000"/>
+              </a:srgbClr>
+            </a:outerShdw>
+          </a:effectLst>
         </p:spPr>
       </p:sp>
       <p:sp>
@@ -8705,11 +8831,11 @@
             </a:avLst>
           </a:prstGeom>
           <a:solidFill>
-            <a:srgbClr val="0E0E15"/>
+            <a:srgbClr val="F1ECFD"/>
           </a:solidFill>
           <a:ln w="15875">
             <a:solidFill>
-              <a:srgbClr val="8B5CF6"/>
+              <a:srgbClr val="6D28D9"/>
             </a:solidFill>
             <a:prstDash val="solid"/>
           </a:ln>
@@ -8742,7 +8868,7 @@
             <a:r>
               <a:rPr lang="en-US" sz="1600" b="1" dirty="0">
                 <a:solidFill>
-                  <a:srgbClr val="8B5CF6"/>
+                  <a:srgbClr val="6D28D9"/>
                 </a:solidFill>
                 <a:latin typeface="Courier New" pitchFamily="34" charset="0"/>
                 <a:ea typeface="Courier New" pitchFamily="34" charset="-122"/>
@@ -8781,7 +8907,7 @@
             <a:r>
               <a:rPr lang="en-US" sz="1400" b="1" dirty="0">
                 <a:solidFill>
-                  <a:srgbClr val="F5F5F7"/>
+                  <a:srgbClr val="16171F"/>
                 </a:solidFill>
                 <a:latin typeface="Arial" pitchFamily="34" charset="0"/>
                 <a:ea typeface="Arial" pitchFamily="34" charset="-122"/>
@@ -8820,7 +8946,7 @@
             <a:r>
               <a:rPr lang="en-US" sz="1050" dirty="0">
                 <a:solidFill>
-                  <a:srgbClr val="9CA0AE"/>
+                  <a:srgbClr val="5C6472"/>
                 </a:solidFill>
                 <a:latin typeface="Calibri" pitchFamily="34" charset="0"/>
                 <a:ea typeface="Calibri" pitchFamily="34" charset="-122"/>
@@ -8862,7 +8988,7 @@
             <a:r>
               <a:rPr lang="en-US" sz="1400" i="1" dirty="0">
                 <a:solidFill>
-                  <a:srgbClr val="9CA0AE"/>
+                  <a:srgbClr val="5C6472"/>
                 </a:solidFill>
                 <a:latin typeface="Calibri" pitchFamily="34" charset="0"/>
                 <a:ea typeface="Calibri" pitchFamily="34" charset="-122"/>
@@ -8888,7 +9014,7 @@
     <p:bg>
       <p:bgPr>
         <a:solidFill>
-          <a:srgbClr val="0B0B0F"/>
+          <a:srgbClr val="F7F8FA"/>
         </a:solidFill>
       </p:bgPr>
     </p:bg>
@@ -8921,7 +9047,7 @@
             <a:avLst/>
           </a:prstGeom>
           <a:solidFill>
-            <a:srgbClr val="8B5CF6"/>
+            <a:srgbClr val="6D28D9"/>
           </a:solidFill>
           <a:ln/>
         </p:spPr>
@@ -8953,7 +9079,7 @@
             <a:r>
               <a:rPr lang="en-US" sz="1100" b="1" spc="200" kern="0" dirty="0">
                 <a:solidFill>
-                  <a:srgbClr val="8B5CF6"/>
+                  <a:srgbClr val="6D28D9"/>
                 </a:solidFill>
                 <a:latin typeface="Courier New" pitchFamily="34" charset="0"/>
                 <a:ea typeface="Courier New" pitchFamily="34" charset="-122"/>
@@ -8995,7 +9121,7 @@
             <a:r>
               <a:rPr lang="en-US" sz="2900" b="1" dirty="0">
                 <a:solidFill>
-                  <a:srgbClr val="F5F5F7"/>
+                  <a:srgbClr val="16171F"/>
                 </a:solidFill>
                 <a:latin typeface="Arial" pitchFamily="34" charset="0"/>
                 <a:ea typeface="Arial" pitchFamily="34" charset="-122"/>
@@ -9034,7 +9160,7 @@
             <a:r>
               <a:rPr lang="en-US" sz="800" spc="200" kern="0" dirty="0">
                 <a:solidFill>
-                  <a:srgbClr val="6B7280"/>
+                  <a:srgbClr val="9AA0AC"/>
                 </a:solidFill>
                 <a:latin typeface="Courier New" pitchFamily="34" charset="0"/>
                 <a:ea typeface="Courier New" pitchFamily="34" charset="-122"/>
@@ -9073,7 +9199,7 @@
             <a:r>
               <a:rPr lang="en-US" sz="800" dirty="0">
                 <a:solidFill>
-                  <a:srgbClr val="6B7280"/>
+                  <a:srgbClr val="9AA0AC"/>
                 </a:solidFill>
                 <a:latin typeface="Courier New" pitchFamily="34" charset="0"/>
                 <a:ea typeface="Courier New" pitchFamily="34" charset="-122"/>
@@ -9102,14 +9228,21 @@
             </a:avLst>
           </a:prstGeom>
           <a:solidFill>
-            <a:srgbClr val="16161C"/>
+            <a:srgbClr val="FFFFFF"/>
           </a:solidFill>
           <a:ln w="12700">
             <a:solidFill>
-              <a:srgbClr val="24242E"/>
+              <a:srgbClr val="E4E7ED"/>
             </a:solidFill>
             <a:prstDash val="solid"/>
           </a:ln>
+          <a:effectLst>
+            <a:outerShdw sx="100000" sy="100000" kx="0" ky="0" algn="bl" rotWithShape="0" blurRad="101600" dist="25400" dir="5400000">
+              <a:srgbClr val="9AA3B2">
+                <a:alpha val="22000"/>
+              </a:srgbClr>
+            </a:outerShdw>
+          </a:effectLst>
         </p:spPr>
       </p:sp>
       <p:sp>
@@ -9127,7 +9260,7 @@
             <a:avLst/>
           </a:prstGeom>
           <a:solidFill>
-            <a:srgbClr val="8B5CF6"/>
+            <a:srgbClr val="6D28D9"/>
           </a:solidFill>
           <a:ln/>
         </p:spPr>
@@ -9162,7 +9295,7 @@
             <a:r>
               <a:rPr lang="en-US" sz="1450" b="1" dirty="0">
                 <a:solidFill>
-                  <a:srgbClr val="F5F5F7"/>
+                  <a:srgbClr val="16171F"/>
                 </a:solidFill>
                 <a:latin typeface="Arial" pitchFamily="34" charset="0"/>
                 <a:ea typeface="Arial" pitchFamily="34" charset="-122"/>
@@ -9204,7 +9337,7 @@
             <a:r>
               <a:rPr lang="en-US" sz="1200" dirty="0">
                 <a:solidFill>
-                  <a:srgbClr val="9CA0AE"/>
+                  <a:srgbClr val="5C6472"/>
                 </a:solidFill>
                 <a:latin typeface="Calibri" pitchFamily="34" charset="0"/>
                 <a:ea typeface="Calibri" pitchFamily="34" charset="-122"/>
@@ -9233,14 +9366,21 @@
             </a:avLst>
           </a:prstGeom>
           <a:solidFill>
-            <a:srgbClr val="16161C"/>
+            <a:srgbClr val="FFFFFF"/>
           </a:solidFill>
           <a:ln w="12700">
             <a:solidFill>
-              <a:srgbClr val="24242E"/>
+              <a:srgbClr val="E4E7ED"/>
             </a:solidFill>
             <a:prstDash val="solid"/>
           </a:ln>
+          <a:effectLst>
+            <a:outerShdw sx="100000" sy="100000" kx="0" ky="0" algn="bl" rotWithShape="0" blurRad="101600" dist="25400" dir="5400000">
+              <a:srgbClr val="9AA3B2">
+                <a:alpha val="22000"/>
+              </a:srgbClr>
+            </a:outerShdw>
+          </a:effectLst>
         </p:spPr>
       </p:sp>
       <p:sp>
@@ -9258,7 +9398,7 @@
             <a:avLst/>
           </a:prstGeom>
           <a:solidFill>
-            <a:srgbClr val="8B5CF6"/>
+            <a:srgbClr val="6D28D9"/>
           </a:solidFill>
           <a:ln/>
         </p:spPr>
@@ -9293,7 +9433,7 @@
             <a:r>
               <a:rPr lang="en-US" sz="1450" b="1" dirty="0">
                 <a:solidFill>
-                  <a:srgbClr val="F5F5F7"/>
+                  <a:srgbClr val="16171F"/>
                 </a:solidFill>
                 <a:latin typeface="Arial" pitchFamily="34" charset="0"/>
                 <a:ea typeface="Arial" pitchFamily="34" charset="-122"/>
@@ -9335,7 +9475,7 @@
             <a:r>
               <a:rPr lang="en-US" sz="1200" dirty="0">
                 <a:solidFill>
-                  <a:srgbClr val="9CA0AE"/>
+                  <a:srgbClr val="5C6472"/>
                 </a:solidFill>
                 <a:latin typeface="Calibri" pitchFamily="34" charset="0"/>
                 <a:ea typeface="Calibri" pitchFamily="34" charset="-122"/>
@@ -9364,14 +9504,21 @@
             </a:avLst>
           </a:prstGeom>
           <a:solidFill>
-            <a:srgbClr val="16161C"/>
+            <a:srgbClr val="FFFFFF"/>
           </a:solidFill>
           <a:ln w="12700">
             <a:solidFill>
-              <a:srgbClr val="24242E"/>
+              <a:srgbClr val="E4E7ED"/>
             </a:solidFill>
             <a:prstDash val="solid"/>
           </a:ln>
+          <a:effectLst>
+            <a:outerShdw sx="100000" sy="100000" kx="0" ky="0" algn="bl" rotWithShape="0" blurRad="101600" dist="25400" dir="5400000">
+              <a:srgbClr val="9AA3B2">
+                <a:alpha val="22000"/>
+              </a:srgbClr>
+            </a:outerShdw>
+          </a:effectLst>
         </p:spPr>
       </p:sp>
       <p:sp>
@@ -9389,7 +9536,7 @@
             <a:avLst/>
           </a:prstGeom>
           <a:solidFill>
-            <a:srgbClr val="8B5CF6"/>
+            <a:srgbClr val="6D28D9"/>
           </a:solidFill>
           <a:ln/>
         </p:spPr>
@@ -9424,7 +9571,7 @@
             <a:r>
               <a:rPr lang="en-US" sz="1450" b="1" dirty="0">
                 <a:solidFill>
-                  <a:srgbClr val="F5F5F7"/>
+                  <a:srgbClr val="16171F"/>
                 </a:solidFill>
                 <a:latin typeface="Arial" pitchFamily="34" charset="0"/>
                 <a:ea typeface="Arial" pitchFamily="34" charset="-122"/>
@@ -9466,7 +9613,7 @@
             <a:r>
               <a:rPr lang="en-US" sz="1200" dirty="0">
                 <a:solidFill>
-                  <a:srgbClr val="9CA0AE"/>
+                  <a:srgbClr val="5C6472"/>
                 </a:solidFill>
                 <a:latin typeface="Calibri" pitchFamily="34" charset="0"/>
                 <a:ea typeface="Calibri" pitchFamily="34" charset="-122"/>
@@ -9495,14 +9642,21 @@
             </a:avLst>
           </a:prstGeom>
           <a:solidFill>
-            <a:srgbClr val="16161C"/>
+            <a:srgbClr val="FFFFFF"/>
           </a:solidFill>
           <a:ln w="12700">
             <a:solidFill>
-              <a:srgbClr val="24242E"/>
+              <a:srgbClr val="E4E7ED"/>
             </a:solidFill>
             <a:prstDash val="solid"/>
           </a:ln>
+          <a:effectLst>
+            <a:outerShdw sx="100000" sy="100000" kx="0" ky="0" algn="bl" rotWithShape="0" blurRad="101600" dist="25400" dir="5400000">
+              <a:srgbClr val="9AA3B2">
+                <a:alpha val="22000"/>
+              </a:srgbClr>
+            </a:outerShdw>
+          </a:effectLst>
         </p:spPr>
       </p:sp>
       <p:sp>
@@ -9520,7 +9674,7 @@
             <a:avLst/>
           </a:prstGeom>
           <a:solidFill>
-            <a:srgbClr val="8B5CF6"/>
+            <a:srgbClr val="6D28D9"/>
           </a:solidFill>
           <a:ln/>
         </p:spPr>
@@ -9555,7 +9709,7 @@
             <a:r>
               <a:rPr lang="en-US" sz="1450" b="1" dirty="0">
                 <a:solidFill>
-                  <a:srgbClr val="F5F5F7"/>
+                  <a:srgbClr val="16171F"/>
                 </a:solidFill>
                 <a:latin typeface="Arial" pitchFamily="34" charset="0"/>
                 <a:ea typeface="Arial" pitchFamily="34" charset="-122"/>
@@ -9597,7 +9751,7 @@
             <a:r>
               <a:rPr lang="en-US" sz="1200" dirty="0">
                 <a:solidFill>
-                  <a:srgbClr val="9CA0AE"/>
+                  <a:srgbClr val="5C6472"/>
                 </a:solidFill>
                 <a:latin typeface="Calibri" pitchFamily="34" charset="0"/>
                 <a:ea typeface="Calibri" pitchFamily="34" charset="-122"/>
@@ -9626,11 +9780,11 @@
             </a:avLst>
           </a:prstGeom>
           <a:solidFill>
-            <a:srgbClr val="16161C"/>
+            <a:srgbClr val="FFFFFF"/>
           </a:solidFill>
           <a:ln w="12700">
             <a:solidFill>
-              <a:srgbClr val="E1348B"/>
+              <a:srgbClr val="DB2777"/>
             </a:solidFill>
             <a:prstDash val="solid"/>
           </a:ln>
@@ -9663,7 +9817,7 @@
             <a:r>
               <a:rPr lang="en-US" sz="1050" spc="100" kern="0" dirty="0">
                 <a:solidFill>
-                  <a:srgbClr val="F5F5F7"/>
+                  <a:srgbClr val="16171F"/>
                 </a:solidFill>
                 <a:latin typeface="Courier New" pitchFamily="34" charset="0"/>
                 <a:ea typeface="Courier New" pitchFamily="34" charset="-122"/>
@@ -9692,11 +9846,11 @@
             </a:avLst>
           </a:prstGeom>
           <a:solidFill>
-            <a:srgbClr val="16161C"/>
+            <a:srgbClr val="FFFFFF"/>
           </a:solidFill>
           <a:ln w="12700">
             <a:solidFill>
-              <a:srgbClr val="E1348B"/>
+              <a:srgbClr val="DB2777"/>
             </a:solidFill>
             <a:prstDash val="solid"/>
           </a:ln>
@@ -9729,7 +9883,7 @@
             <a:r>
               <a:rPr lang="en-US" sz="1050" spc="100" kern="0" dirty="0">
                 <a:solidFill>
-                  <a:srgbClr val="F5F5F7"/>
+                  <a:srgbClr val="16171F"/>
                 </a:solidFill>
                 <a:latin typeface="Courier New" pitchFamily="34" charset="0"/>
                 <a:ea typeface="Courier New" pitchFamily="34" charset="-122"/>
@@ -9758,11 +9912,11 @@
             </a:avLst>
           </a:prstGeom>
           <a:solidFill>
-            <a:srgbClr val="16161C"/>
+            <a:srgbClr val="FFFFFF"/>
           </a:solidFill>
           <a:ln w="12700">
             <a:solidFill>
-              <a:srgbClr val="E1348B"/>
+              <a:srgbClr val="DB2777"/>
             </a:solidFill>
             <a:prstDash val="solid"/>
           </a:ln>
@@ -9795,7 +9949,7 @@
             <a:r>
               <a:rPr lang="en-US" sz="1050" spc="100" kern="0" dirty="0">
                 <a:solidFill>
-                  <a:srgbClr val="F5F5F7"/>
+                  <a:srgbClr val="16171F"/>
                 </a:solidFill>
                 <a:latin typeface="Courier New" pitchFamily="34" charset="0"/>
                 <a:ea typeface="Courier New" pitchFamily="34" charset="-122"/>
@@ -9824,11 +9978,11 @@
             </a:avLst>
           </a:prstGeom>
           <a:solidFill>
-            <a:srgbClr val="16161C"/>
+            <a:srgbClr val="FFFFFF"/>
           </a:solidFill>
           <a:ln w="12700">
             <a:solidFill>
-              <a:srgbClr val="E1348B"/>
+              <a:srgbClr val="DB2777"/>
             </a:solidFill>
             <a:prstDash val="solid"/>
           </a:ln>
@@ -9861,7 +10015,7 @@
             <a:r>
               <a:rPr lang="en-US" sz="1050" spc="100" kern="0" dirty="0">
                 <a:solidFill>
-                  <a:srgbClr val="F5F5F7"/>
+                  <a:srgbClr val="16171F"/>
                 </a:solidFill>
                 <a:latin typeface="Courier New" pitchFamily="34" charset="0"/>
                 <a:ea typeface="Courier New" pitchFamily="34" charset="-122"/>
@@ -9887,7 +10041,7 @@
     <p:bg>
       <p:bgPr>
         <a:solidFill>
-          <a:srgbClr val="0B0B0F"/>
+          <a:srgbClr val="F7F8FA"/>
         </a:solidFill>
       </p:bgPr>
     </p:bg>
@@ -9920,7 +10074,7 @@
             <a:avLst/>
           </a:prstGeom>
           <a:solidFill>
-            <a:srgbClr val="8B5CF6"/>
+            <a:srgbClr val="6D28D9"/>
           </a:solidFill>
           <a:ln/>
         </p:spPr>
@@ -9952,7 +10106,7 @@
             <a:r>
               <a:rPr lang="en-US" sz="1100" b="1" spc="200" kern="0" dirty="0">
                 <a:solidFill>
-                  <a:srgbClr val="8B5CF6"/>
+                  <a:srgbClr val="6D28D9"/>
                 </a:solidFill>
                 <a:latin typeface="Courier New" pitchFamily="34" charset="0"/>
                 <a:ea typeface="Courier New" pitchFamily="34" charset="-122"/>
@@ -9994,7 +10148,7 @@
             <a:r>
               <a:rPr lang="en-US" sz="2900" b="1" dirty="0">
                 <a:solidFill>
-                  <a:srgbClr val="F5F5F7"/>
+                  <a:srgbClr val="16171F"/>
                 </a:solidFill>
                 <a:latin typeface="Arial" pitchFamily="34" charset="0"/>
                 <a:ea typeface="Arial" pitchFamily="34" charset="-122"/>
@@ -10033,7 +10187,7 @@
             <a:r>
               <a:rPr lang="en-US" sz="800" spc="200" kern="0" dirty="0">
                 <a:solidFill>
-                  <a:srgbClr val="6B7280"/>
+                  <a:srgbClr val="9AA0AC"/>
                 </a:solidFill>
                 <a:latin typeface="Courier New" pitchFamily="34" charset="0"/>
                 <a:ea typeface="Courier New" pitchFamily="34" charset="-122"/>
@@ -10072,7 +10226,7 @@
             <a:r>
               <a:rPr lang="en-US" sz="800" dirty="0">
                 <a:solidFill>
-                  <a:srgbClr val="6B7280"/>
+                  <a:srgbClr val="9AA0AC"/>
                 </a:solidFill>
                 <a:latin typeface="Courier New" pitchFamily="34" charset="0"/>
                 <a:ea typeface="Courier New" pitchFamily="34" charset="-122"/>
@@ -10105,14 +10259,14 @@
           </a:solidFill>
           <a:ln w="12700">
             <a:solidFill>
-              <a:srgbClr val="24242E"/>
+              <a:srgbClr val="E4E7ED"/>
             </a:solidFill>
             <a:prstDash val="solid"/>
           </a:ln>
           <a:effectLst>
-            <a:outerShdw sx="100000" sy="100000" kx="0" ky="0" algn="bl" rotWithShape="0" blurRad="203200" dist="50800" dir="5400000">
-              <a:srgbClr val="000000">
-                <a:alpha val="45000"/>
+            <a:outerShdw sx="100000" sy="100000" kx="0" ky="0" algn="bl" rotWithShape="0" blurRad="139700" dist="38100" dir="5400000">
+              <a:srgbClr val="8A93A6">
+                <a:alpha val="30000"/>
               </a:srgbClr>
             </a:outerShdw>
           </a:effectLst>
@@ -10172,7 +10326,7 @@
             <a:r>
               <a:rPr lang="en-US" sz="1300" i="1" dirty="0">
                 <a:solidFill>
-                  <a:srgbClr val="9CA0AE"/>
+                  <a:srgbClr val="5C6472"/>
                 </a:solidFill>
                 <a:latin typeface="Calibri" pitchFamily="34" charset="0"/>
                 <a:ea typeface="Calibri" pitchFamily="34" charset="-122"/>
@@ -10198,7 +10352,7 @@
     <p:bg>
       <p:bgPr>
         <a:solidFill>
-          <a:srgbClr val="0B0B0F"/>
+          <a:srgbClr val="F7F8FA"/>
         </a:solidFill>
       </p:bgPr>
     </p:bg>
@@ -10231,7 +10385,7 @@
             <a:avLst/>
           </a:prstGeom>
           <a:solidFill>
-            <a:srgbClr val="8B5CF6"/>
+            <a:srgbClr val="6D28D9"/>
           </a:solidFill>
           <a:ln/>
         </p:spPr>
@@ -10263,7 +10417,7 @@
             <a:r>
               <a:rPr lang="en-US" sz="1100" b="1" spc="200" kern="0" dirty="0">
                 <a:solidFill>
-                  <a:srgbClr val="8B5CF6"/>
+                  <a:srgbClr val="6D28D9"/>
                 </a:solidFill>
                 <a:latin typeface="Courier New" pitchFamily="34" charset="0"/>
                 <a:ea typeface="Courier New" pitchFamily="34" charset="-122"/>
@@ -10305,7 +10459,7 @@
             <a:r>
               <a:rPr lang="en-US" sz="2900" b="1" dirty="0">
                 <a:solidFill>
-                  <a:srgbClr val="F5F5F7"/>
+                  <a:srgbClr val="16171F"/>
                 </a:solidFill>
                 <a:latin typeface="Arial" pitchFamily="34" charset="0"/>
                 <a:ea typeface="Arial" pitchFamily="34" charset="-122"/>
@@ -10344,7 +10498,7 @@
             <a:r>
               <a:rPr lang="en-US" sz="800" spc="200" kern="0" dirty="0">
                 <a:solidFill>
-                  <a:srgbClr val="6B7280"/>
+                  <a:srgbClr val="9AA0AC"/>
                 </a:solidFill>
                 <a:latin typeface="Courier New" pitchFamily="34" charset="0"/>
                 <a:ea typeface="Courier New" pitchFamily="34" charset="-122"/>
@@ -10383,7 +10537,7 @@
             <a:r>
               <a:rPr lang="en-US" sz="800" dirty="0">
                 <a:solidFill>
-                  <a:srgbClr val="6B7280"/>
+                  <a:srgbClr val="9AA0AC"/>
                 </a:solidFill>
                 <a:latin typeface="Courier New" pitchFamily="34" charset="0"/>
                 <a:ea typeface="Courier New" pitchFamily="34" charset="-122"/>
@@ -10416,14 +10570,14 @@
           </a:solidFill>
           <a:ln w="12700">
             <a:solidFill>
-              <a:srgbClr val="24242E"/>
+              <a:srgbClr val="E4E7ED"/>
             </a:solidFill>
             <a:prstDash val="solid"/>
           </a:ln>
           <a:effectLst>
-            <a:outerShdw sx="100000" sy="100000" kx="0" ky="0" algn="bl" rotWithShape="0" blurRad="203200" dist="50800" dir="5400000">
-              <a:srgbClr val="000000">
-                <a:alpha val="45000"/>
+            <a:outerShdw sx="100000" sy="100000" kx="0" ky="0" algn="bl" rotWithShape="0" blurRad="139700" dist="38100" dir="5400000">
+              <a:srgbClr val="8A93A6">
+                <a:alpha val="30000"/>
               </a:srgbClr>
             </a:outerShdw>
           </a:effectLst>
@@ -10483,7 +10637,7 @@
             <a:r>
               <a:rPr lang="en-US" sz="1300" i="1" dirty="0">
                 <a:solidFill>
-                  <a:srgbClr val="9CA0AE"/>
+                  <a:srgbClr val="5C6472"/>
                 </a:solidFill>
                 <a:latin typeface="Calibri" pitchFamily="34" charset="0"/>
                 <a:ea typeface="Calibri" pitchFamily="34" charset="-122"/>
@@ -10509,7 +10663,7 @@
     <p:bg>
       <p:bgPr>
         <a:solidFill>
-          <a:srgbClr val="0B0B0F"/>
+          <a:srgbClr val="F7F8FA"/>
         </a:solidFill>
       </p:bgPr>
     </p:bg>
@@ -10542,7 +10696,7 @@
             <a:avLst/>
           </a:prstGeom>
           <a:solidFill>
-            <a:srgbClr val="8B5CF6"/>
+            <a:srgbClr val="6D28D9"/>
           </a:solidFill>
           <a:ln/>
         </p:spPr>
@@ -10574,7 +10728,7 @@
             <a:r>
               <a:rPr lang="en-US" sz="1100" b="1" spc="200" kern="0" dirty="0">
                 <a:solidFill>
-                  <a:srgbClr val="8B5CF6"/>
+                  <a:srgbClr val="6D28D9"/>
                 </a:solidFill>
                 <a:latin typeface="Courier New" pitchFamily="34" charset="0"/>
                 <a:ea typeface="Courier New" pitchFamily="34" charset="-122"/>
@@ -10616,7 +10770,7 @@
             <a:r>
               <a:rPr lang="en-US" sz="2900" b="1" dirty="0">
                 <a:solidFill>
-                  <a:srgbClr val="F5F5F7"/>
+                  <a:srgbClr val="16171F"/>
                 </a:solidFill>
                 <a:latin typeface="Arial" pitchFamily="34" charset="0"/>
                 <a:ea typeface="Arial" pitchFamily="34" charset="-122"/>
@@ -10655,7 +10809,7 @@
             <a:r>
               <a:rPr lang="en-US" sz="800" spc="200" kern="0" dirty="0">
                 <a:solidFill>
-                  <a:srgbClr val="6B7280"/>
+                  <a:srgbClr val="9AA0AC"/>
                 </a:solidFill>
                 <a:latin typeface="Courier New" pitchFamily="34" charset="0"/>
                 <a:ea typeface="Courier New" pitchFamily="34" charset="-122"/>
@@ -10694,7 +10848,7 @@
             <a:r>
               <a:rPr lang="en-US" sz="800" dirty="0">
                 <a:solidFill>
-                  <a:srgbClr val="6B7280"/>
+                  <a:srgbClr val="9AA0AC"/>
                 </a:solidFill>
                 <a:latin typeface="Courier New" pitchFamily="34" charset="0"/>
                 <a:ea typeface="Courier New" pitchFamily="34" charset="-122"/>
@@ -10727,14 +10881,14 @@
           </a:solidFill>
           <a:ln w="12700">
             <a:solidFill>
-              <a:srgbClr val="24242E"/>
+              <a:srgbClr val="E4E7ED"/>
             </a:solidFill>
             <a:prstDash val="solid"/>
           </a:ln>
           <a:effectLst>
-            <a:outerShdw sx="100000" sy="100000" kx="0" ky="0" algn="bl" rotWithShape="0" blurRad="203200" dist="50800" dir="5400000">
-              <a:srgbClr val="000000">
-                <a:alpha val="45000"/>
+            <a:outerShdw sx="100000" sy="100000" kx="0" ky="0" algn="bl" rotWithShape="0" blurRad="139700" dist="38100" dir="5400000">
+              <a:srgbClr val="8A93A6">
+                <a:alpha val="30000"/>
               </a:srgbClr>
             </a:outerShdw>
           </a:effectLst>
@@ -10794,7 +10948,7 @@
             <a:r>
               <a:rPr lang="en-US" sz="1300" i="1" dirty="0">
                 <a:solidFill>
-                  <a:srgbClr val="9CA0AE"/>
+                  <a:srgbClr val="5C6472"/>
                 </a:solidFill>
                 <a:latin typeface="Calibri" pitchFamily="34" charset="0"/>
                 <a:ea typeface="Calibri" pitchFamily="34" charset="-122"/>

</xml_diff>

<commit_message>
fix(deck): enlarge tall screenshots on slides 11 (deny) & 12 (change detector)
Drop the bottom caption and maximize image height on the two tall demo shots so
the answer/diff text is more readable; keep clear of the slide title and footer.

Co-Authored-By: Claude Opus 4.8 <noreply@anthropic.com>
</commit_message>
<xml_diff>
--- a/presentation/Clinical_Policy_RAG.pptx
+++ b/presentation/Clinical_Policy_RAG.pptx
@@ -2877,7 +2877,7 @@
                 <a:ea typeface="Courier New" pitchFamily="34" charset="-122"/>
                 <a:cs typeface="Courier New" pitchFamily="34" charset="-120"/>
               </a:rPr>
-              <a:t>LIVE DEMO · CLAIM ADJUDICATION</a:t>
+              <a:t>LIVE DEMO · CLAIM ADJUDICATION · CLM-2042 = FLAG / DENY</a:t>
             </a:r>
             <a:endParaRPr lang="en-US" sz="1100" dirty="0"/>
           </a:p>
@@ -3028,12 +3028,12 @@
         </p:nvSpPr>
         <p:spPr>
           <a:xfrm>
-            <a:off x="4227044" y="1545336"/>
-            <a:ext cx="3737608" cy="4270248"/>
+            <a:off x="3984658" y="1417320"/>
+            <a:ext cx="4222378" cy="4828032"/>
           </a:xfrm>
           <a:prstGeom prst="roundRect">
             <a:avLst>
-              <a:gd name="adj" fmla="val 1957"/>
+              <a:gd name="adj" fmla="val 1732"/>
             </a:avLst>
           </a:prstGeom>
           <a:solidFill>
@@ -3070,56 +3070,14 @@
         </p:blipFill>
         <p:spPr>
           <a:xfrm>
-            <a:off x="4327628" y="1645920"/>
-            <a:ext cx="3536440" cy="4069080"/>
+            <a:off x="4085242" y="1517904"/>
+            <a:ext cx="4021210" cy="4626864"/>
           </a:xfrm>
           <a:prstGeom prst="rect">
             <a:avLst/>
           </a:prstGeom>
         </p:spPr>
       </p:pic>
-      <p:sp>
-        <p:nvSpPr>
-          <p:cNvPr id="9" name="Text 6"/>
-          <p:cNvSpPr/>
-          <p:nvPr/>
-        </p:nvSpPr>
-        <p:spPr>
-          <a:xfrm>
-            <a:off x="566928" y="5806440"/>
-            <a:ext cx="11057839" cy="457200"/>
-          </a:xfrm>
-          <a:prstGeom prst="rect">
-            <a:avLst/>
-          </a:prstGeom>
-          <a:noFill/>
-          <a:ln/>
-        </p:spPr>
-        <p:txBody>
-          <a:bodyPr wrap="square" rtlCol="0" anchor="ctr"/>
-          <a:lstStyle/>
-          <a:p>
-            <a:pPr algn="ctr" indent="0" marL="0">
-              <a:lnSpc>
-                <a:spcPts val="1600"/>
-              </a:lnSpc>
-              <a:buNone/>
-            </a:pPr>
-            <a:r>
-              <a:rPr lang="en-US" sz="1300" i="1" dirty="0">
-                <a:solidFill>
-                  <a:srgbClr val="5C6472"/>
-                </a:solidFill>
-                <a:latin typeface="Calibri" pitchFamily="34" charset="0"/>
-                <a:ea typeface="Calibri" pitchFamily="34" charset="-122"/>
-                <a:cs typeface="Calibri" pitchFamily="34" charset="-120"/>
-              </a:rPr>
-              <a:t>Same policy, same prompt, different claim — no conservative care documented, so the tool flags the exact missing requirement.</a:t>
-            </a:r>
-            <a:endParaRPr lang="en-US" sz="1300" dirty="0"/>
-          </a:p>
-        </p:txBody>
-      </p:sp>
     </p:spTree>
   </p:cSld>
   <p:clrMapOvr>
@@ -3205,7 +3163,7 @@
                 <a:ea typeface="Courier New" pitchFamily="34" charset="-122"/>
                 <a:cs typeface="Courier New" pitchFamily="34" charset="-120"/>
               </a:rPr>
-              <a:t>LIVE DEMO · POLICY CHANGE DETECTOR</a:t>
+              <a:t>LIVE DEMO · POLICY CHANGE DETECTOR · telehealth 2024 → 2025</a:t>
             </a:r>
             <a:endParaRPr lang="en-US" sz="1100" dirty="0"/>
           </a:p>
@@ -3339,12 +3297,12 @@
         </p:nvSpPr>
         <p:spPr>
           <a:xfrm>
-            <a:off x="4464964" y="1499616"/>
-            <a:ext cx="3231592" cy="4361688"/>
+            <a:off x="4310214" y="1417320"/>
+            <a:ext cx="3571266" cy="4828032"/>
           </a:xfrm>
           <a:prstGeom prst="roundRect">
             <a:avLst>
-              <a:gd name="adj" fmla="val 2264"/>
+              <a:gd name="adj" fmla="val 2048"/>
             </a:avLst>
           </a:prstGeom>
           <a:solidFill>
@@ -3381,56 +3339,14 @@
         </p:blipFill>
         <p:spPr>
           <a:xfrm>
-            <a:off x="4565548" y="1600200"/>
-            <a:ext cx="3030424" cy="4160520"/>
+            <a:off x="4410798" y="1517904"/>
+            <a:ext cx="3370098" cy="4626864"/>
           </a:xfrm>
           <a:prstGeom prst="rect">
             <a:avLst/>
           </a:prstGeom>
         </p:spPr>
       </p:pic>
-      <p:sp>
-        <p:nvSpPr>
-          <p:cNvPr id="9" name="Text 6"/>
-          <p:cNvSpPr/>
-          <p:nvPr/>
-        </p:nvSpPr>
-        <p:spPr>
-          <a:xfrm>
-            <a:off x="566928" y="5806440"/>
-            <a:ext cx="11057839" cy="457200"/>
-          </a:xfrm>
-          <a:prstGeom prst="rect">
-            <a:avLst/>
-          </a:prstGeom>
-          <a:noFill/>
-          <a:ln/>
-        </p:spPr>
-        <p:txBody>
-          <a:bodyPr wrap="square" rtlCol="0" anchor="ctr"/>
-          <a:lstStyle/>
-          <a:p>
-            <a:pPr algn="ctr" indent="0" marL="0">
-              <a:lnSpc>
-                <a:spcPts val="1600"/>
-              </a:lnSpc>
-              <a:buNone/>
-            </a:pPr>
-            <a:r>
-              <a:rPr lang="en-US" sz="1300" i="1" dirty="0">
-                <a:solidFill>
-                  <a:srgbClr val="5C6472"/>
-                </a:solidFill>
-                <a:latin typeface="Calibri" pitchFamily="34" charset="0"/>
-                <a:ea typeface="Calibri" pitchFamily="34" charset="-122"/>
-                <a:cs typeface="Calibri" pitchFamily="34" charset="-120"/>
-              </a:rPr>
-              <a:t>telehealth_coverage_2024.md → telehealth_coverage_2025.md — tightened, loosened, added or removed, with the likely claim impact.</a:t>
-            </a:r>
-            <a:endParaRPr lang="en-US" sz="1300" dirty="0"/>
-          </a:p>
-        </p:txBody>
-      </p:sp>
     </p:spTree>
   </p:cSld>
   <p:clrMapOvr>

</xml_diff>

<commit_message>
fix(deck): crop change-detector to 3 rows so slide 12 text is readable
Keep the CLARIFIED / CHANGED / LOOSENED rows (variety of change types); the
shorter aspect lets the diff render much larger on the slide.

Co-Authored-By: Claude Opus 4.8 <noreply@anthropic.com>
</commit_message>
<xml_diff>
--- a/presentation/Clinical_Policy_RAG.pptx
+++ b/presentation/Clinical_Policy_RAG.pptx
@@ -3297,12 +3297,12 @@
         </p:nvSpPr>
         <p:spPr>
           <a:xfrm>
-            <a:off x="4310214" y="1417320"/>
-            <a:ext cx="3571266" cy="4828032"/>
+            <a:off x="3366986" y="1417320"/>
+            <a:ext cx="5457724" cy="4828032"/>
           </a:xfrm>
           <a:prstGeom prst="roundRect">
             <a:avLst>
-              <a:gd name="adj" fmla="val 2048"/>
+              <a:gd name="adj" fmla="val 1515"/>
             </a:avLst>
           </a:prstGeom>
           <a:solidFill>
@@ -3325,7 +3325,7 @@
       </p:sp>
       <p:pic>
         <p:nvPicPr>
-          <p:cNvPr id="8" name="Image 0" descr="/Users/iymanahmed/Documents/New project/clinical-rag-poc/presentation/shots/change_detector.png">    </p:cNvPr>
+          <p:cNvPr id="8" name="Image 0" descr="/Users/iymanahmed/Documents/New project/clinical-rag-poc/presentation/shots/change_detector_3rows.png">    </p:cNvPr>
           <p:cNvPicPr>
             <a:picLocks noChangeAspect="1"/>
           </p:cNvPicPr>
@@ -3339,8 +3339,8 @@
         </p:blipFill>
         <p:spPr>
           <a:xfrm>
-            <a:off x="4410798" y="1517904"/>
-            <a:ext cx="3370098" cy="4626864"/>
+            <a:off x="3467570" y="1517904"/>
+            <a:ext cx="5256556" cy="4626864"/>
           </a:xfrm>
           <a:prstGeom prst="rect">
             <a:avLst/>

</xml_diff>